<commit_message>
Deck exports from version 30: MIT core license
The PDF and PowerPoint still said the server is AGPL-3.0, three slides
behind the relicense.
</commit_message>
<xml_diff>
--- a/docs/presentations/AgentRaaS-deck.pptx
+++ b/docs/presentations/AgentRaaS-deck.pptx
@@ -690,7 +690,7 @@
           <a:p>
             <a:r>
               <a:rPr lang="en-US" dirty="0"/>
-              <a:t>All of the code is public. The server is AGPL-3.0, so anyone can run and change it, with no license key and no limit on actions. The team features, like human approvals and SSO, are source-available and free to run in production on your own servers. Only the Enterprise features, like agent identity, white-label and secret references, need a license. The SDKs and tools are MIT or Apache-2.0.</a:t>
+              <a:t>All of the code is public. The server core is MIT, so anyone can run, change and host it, with no license key and no limit on actions. The team features, like human approvals and SSO, are source-available and free to run in production on your own servers. Only the Enterprise features, like agent identity, white-label and secret references, need a license. The SDKs and tools are MIT too.</a:t>
             </a:r>
             <a:endParaRPr lang="en-US" dirty="0"/>
           </a:p>
@@ -1570,7 +1570,7 @@
           <a:p>
             <a:r>
               <a:rPr lang="en-US" dirty="0"/>
-              <a:t>Anything in the request path has to be fast and trusted. The measured overhead is about two milliseconds. The core is written in Rust. All of the code is public and the core is AGPL-3.0, which matters when the product guards payments, and teams with strict data rules can run it on their own servers next to their data.</a:t>
+              <a:t>Anything in the request path has to be fast and trusted. The measured overhead is about two milliseconds. The core is written in Rust. All of the code is public and the core is MIT, which matters when the product guards payments, and teams with strict data rules can run it on their own servers next to their data.</a:t>
             </a:r>
             <a:endParaRPr lang="en-US" dirty="0"/>
           </a:p>
@@ -3405,7 +3405,7 @@
                           <a:ea typeface="Arial" pitchFamily="34" charset="-122"/>
                           <a:cs typeface="Arial" pitchFamily="34" charset="-120"/>
                         </a:rPr>
-                        <a:t>The server</a:t>
+                        <a:t>The server core</a:t>
                       </a:r>
                       <a:endParaRPr lang="en-US" sz="1200" dirty="0">
                         <a:latin typeface="Arial" charset="0"/>
@@ -3473,7 +3473,7 @@
                           <a:ea typeface="Arial" pitchFamily="34" charset="-122"/>
                           <a:cs typeface="Arial" pitchFamily="34" charset="-120"/>
                         </a:rPr>
-                        <a:t>AGPL-3.0</a:t>
+                        <a:t>MIT</a:t>
                       </a:r>
                       <a:endParaRPr lang="en-US" sz="1200" dirty="0">
                         <a:latin typeface="Arial" charset="0"/>
@@ -3541,7 +3541,7 @@
                           <a:ea typeface="Arial" pitchFamily="34" charset="-122"/>
                           <a:cs typeface="Arial" pitchFamily="34" charset="-120"/>
                         </a:rPr>
-                        <a:t>Use, change and run it for anything. Share your changes if you offer them over a network.</a:t>
+                        <a:t>Use, change, run, host and share it for anything. Keep the notice.</a:t>
                       </a:r>
                       <a:endParaRPr lang="en-US" sz="1200" dirty="0">
                         <a:latin typeface="Arial" charset="0"/>
@@ -3679,7 +3679,7 @@
                           <a:ea typeface="Arial" pitchFamily="34" charset="-122"/>
                           <a:cs typeface="Arial" pitchFamily="34" charset="-120"/>
                         </a:rPr>
-                        <a:t>Source-available</a:t>
+                        <a:t>Enterprise License (source-available)</a:t>
                       </a:r>
                       <a:endParaRPr lang="en-US" sz="1200" dirty="0">
                         <a:latin typeface="Arial" charset="0"/>
@@ -3885,7 +3885,7 @@
                           <a:ea typeface="Arial" pitchFamily="34" charset="-122"/>
                           <a:cs typeface="Arial" pitchFamily="34" charset="-120"/>
                         </a:rPr>
-                        <a:t>MIT or Apache-2.0</a:t>
+                        <a:t>MIT</a:t>
                       </a:r>
                       <a:endParaRPr lang="en-US" sz="1200" dirty="0">
                         <a:latin typeface="Arial" charset="0"/>
@@ -4410,7 +4410,7 @@
                 <a:ea typeface="Arial" pitchFamily="34" charset="-122"/>
                 <a:cs typeface="Arial" pitchFamily="34" charset="-120"/>
               </a:rPr>
-              <a:t>Open source (AGPL), free to self-host on Linux, macOS or Windows</a:t>
+              <a:t>Open source (MIT core), free to self-host on Linux, macOS or Windows</a:t>
             </a:r>
             <a:endParaRPr lang="en-US" sz="1200" dirty="0"/>
           </a:p>
@@ -11289,7 +11289,7 @@
                 <a:ea typeface="Arial" pitchFamily="34" charset="-122"/>
                 <a:cs typeface="Arial" pitchFamily="34" charset="-120"/>
               </a:rPr>
-              <a:t>AGPL-3.0 server and every line of code public: you can read the code that guards your payments.</a:t>
+              <a:t>MIT server core and every line of code public: you can read the code that guards your payments.</a:t>
             </a:r>
             <a:endParaRPr lang="en-US" sz="1200" dirty="0"/>
           </a:p>

</xml_diff>

<commit_message>
Deck PDF and PPTX from v33 (0.28-0.30 features)
</commit_message>
<xml_diff>
--- a/docs/presentations/AgentRaaS-deck.pptx
+++ b/docs/presentations/AgentRaaS-deck.pptx
@@ -778,7 +778,7 @@
           <a:p>
             <a:r>
               <a:rPr lang="en-US" dirty="0"/>
-              <a:t>Everything in this talk is available today. The gateway runs in production, 31 services such as Stripe, Slack, GitHub and Alpaca connect by pasting a key, the Python SDK is on PyPI and the TypeScript SDK on npm. The live demo on agentraas.io needs no signup, and it can be self-hosted at no cost on Linux, macOS or Windows, with no limit on actions.</a:t>
+              <a:t>Everything in this talk is available today. The gateway runs in production, 37 services such as Stripe, Razorpay, Slack, GitHub and Alpaca connect by pasting a key, the Python SDK is on PyPI and the TypeScript SDK on npm. The live demo on agentraas.io needs no signup, and it can be self-hosted at no cost on Linux, macOS or Windows, with no limit on actions.</a:t>
             </a:r>
             <a:endParaRPr lang="en-US" dirty="0"/>
           </a:p>
@@ -1130,7 +1130,7 @@
           <a:p>
             <a:r>
               <a:rPr lang="en-US" dirty="0"/>
-              <a:t>This is what the platform does. Running each call once is where it started; action policies now decide what each agent may do at all, and one integration gives all six controls. Two of the newest: an agent's Stripe charge or Slack message can be undone once from the dashboard, and a recorded run can be replayed in tests without calling the providers again. Everything here is built and running in the product today.</a:t>
+              <a:t>This is what the platform does. Running each call once is where it started; action policies now decide what each agent may do at all, and one integration gives all six controls. The newest: record locks stop two agents changing the same customer or contact at the same moment, and a savings report shows each month how many duplicates were caught, calls blocked and money in duplicate payments stopped. Everything here is built and running in the product today.</a:t>
             </a:r>
             <a:endParaRPr lang="en-US" dirty="0"/>
           </a:p>
@@ -1394,7 +1394,7 @@
           <a:p>
             <a:r>
               <a:rPr lang="en-US" dirty="0"/>
-              <a:t>Two of the newest controls. If an agent did something it should not have, the undo log reverses it: a Stripe refund, a Slack delete, or the reverse action you define for your own actions, sent once with its own idempotency key. Record and replay lets a team test an agent against what real providers answered, without calling them again and without paying for it.</a:t>
+              <a:t>Three ways to lower the risk of a new agent. Shadow mode runs it on real traffic while its writes are checked against your rules and recorded, never sent, so you see what it would have done before it can do anything. Record and replay tests an agent against what real providers answered, without calling them again. And if an agent that is live did something it should not have, the undo log reverses it once: a Stripe refund, a Slack delete, or the reverse action you define.</a:t>
             </a:r>
             <a:endParaRPr lang="en-US" dirty="0"/>
           </a:p>
@@ -1642,16 +1642,9 @@
 </p:sldLayout>
 </file>
 
-<file path=ppt/slideLayouts/slideLayout2.xml><?xml version="1.0" encoding="utf-8"?>
-<p:sldLayout xmlns:a="http://schemas.openxmlformats.org/drawingml/2006/main" xmlns:r="http://schemas.openxmlformats.org/officeDocument/2006/relationships" xmlns:p="http://schemas.openxmlformats.org/presentationml/2006/main" preserve="1">
-  <p:cSld name="Title and body">
-    <p:bg>
-      <p:bgPr>
-        <a:solidFill>
-          <a:srgbClr val="FFFFFF"/>
-        </a:solidFill>
-      </p:bgPr>
-    </p:bg>
+<file path=ppt/slideMasters/slideMaster1.xml><?xml version="1.0" encoding="utf-8"?>
+<p:sldMaster xmlns:a="http://schemas.openxmlformats.org/drawingml/2006/main" xmlns:r="http://schemas.openxmlformats.org/officeDocument/2006/relationships" xmlns:p="http://schemas.openxmlformats.org/presentationml/2006/main">
+  <p:cSld>
     <p:spTree>
       <p:nvGrpSpPr>
         <p:cNvPr id="1" name=""/>
@@ -1666,236 +1659,11 @@
           <a:chExt cx="0" cy="0"/>
         </a:xfrm>
       </p:grpSpPr>
-      <p:sp>
-        <p:nvSpPr>
-          <p:cNvPr id="2" name="Title Placeholder 1"/>
-          <p:cNvSpPr/>
-          <p:nvPr>
-            <p:ph type="title"/>
-          </p:nvPr>
-        </p:nvSpPr>
-        <p:spPr>
-          <a:xfrm>
-            <a:off x="812800" y="1153120"/>
-            <a:ext cx="10566400" cy="502841"/>
-          </a:xfrm>
-          <a:prstGeom prst="rect">
-            <a:avLst/>
-          </a:prstGeom>
-          <a:noFill/>
-          <a:ln/>
-        </p:spPr>
-        <p:txBody>
-          <a:bodyPr wrap="square" lIns="0" tIns="0" rIns="0" bIns="0" rtlCol="0" anchor="t"/>
-          <a:lstStyle>
-            <a:lvl1pPr algn="l" indent="0" marL="0">
-              <a:lnSpc>
-                <a:spcPct val="115000"/>
-              </a:lnSpc>
-              <a:buNone/>
-              <a:defRPr lang="en-US" sz="3600" dirty="0">
-                <a:solidFill>
-                  <a:srgbClr val="16191E"/>
-                </a:solidFill>
-                <a:latin typeface="Arial" pitchFamily="34" charset="0"/>
-                <a:ea typeface="Arial" pitchFamily="34" charset="-122"/>
-                <a:cs typeface="Arial" pitchFamily="34" charset="-120"/>
-              </a:defRPr>
-            </a:lvl1pPr>
-          </a:lstStyle>
-          <a:p>
-            <a:pPr algn="l" indent="0" marL="0">
-              <a:lnSpc>
-                <a:spcPct val="115000"/>
-              </a:lnSpc>
-              <a:buNone/>
-            </a:pPr>
-            <a:endParaRPr lang="en-US" sz="3600" dirty="0"/>
-          </a:p>
-        </p:txBody>
-      </p:sp>
-      <p:sp>
-        <p:nvSpPr>
-          <p:cNvPr id="3" name="Text Placeholder 2"/>
-          <p:cNvSpPr/>
-          <p:nvPr>
-            <p:ph idx="101" type="body"/>
-          </p:nvPr>
-        </p:nvSpPr>
-        <p:spPr>
-          <a:xfrm>
-            <a:off x="812800" y="1960761"/>
-            <a:ext cx="10566400" cy="4084439"/>
-          </a:xfrm>
-          <a:prstGeom prst="rect">
-            <a:avLst/>
-          </a:prstGeom>
-          <a:noFill/>
-          <a:ln/>
-        </p:spPr>
-        <p:txBody>
-          <a:bodyPr wrap="square" lIns="0" tIns="0" rIns="0" bIns="0" rtlCol="0" anchor="t"/>
-          <a:lstStyle>
-            <a:lvl1pPr algn="l" indent="0" marL="0">
-              <a:lnSpc>
-                <a:spcPct val="140000"/>
-              </a:lnSpc>
-              <a:buNone/>
-              <a:defRPr lang="en-US" sz="1600" dirty="0">
-                <a:solidFill>
-                  <a:srgbClr val="16191E"/>
-                </a:solidFill>
-                <a:latin typeface="Arial" pitchFamily="34" charset="0"/>
-                <a:ea typeface="Arial" pitchFamily="34" charset="-122"/>
-                <a:cs typeface="Arial" pitchFamily="34" charset="-120"/>
-              </a:defRPr>
-            </a:lvl1pPr>
-          </a:lstStyle>
-          <a:p>
-            <a:pPr algn="l" indent="0" marL="0">
-              <a:lnSpc>
-                <a:spcPct val="140000"/>
-              </a:lnSpc>
-              <a:buNone/>
-            </a:pPr>
-            <a:endParaRPr lang="en-US" sz="1600" dirty="0"/>
-          </a:p>
-        </p:txBody>
-      </p:sp>
-    </p:spTree>
-  </p:cSld>
-  <p:clrMapOvr>
-    <a:masterClrMapping/>
-  </p:clrMapOvr>
-</p:sldLayout>
-</file>
-
-<file path=ppt/slideMasters/slideMaster1.xml><?xml version="1.0" encoding="utf-8"?>
-<p:sldMaster xmlns:a="http://schemas.openxmlformats.org/drawingml/2006/main" xmlns:r="http://schemas.openxmlformats.org/officeDocument/2006/relationships" xmlns:p="http://schemas.openxmlformats.org/presentationml/2006/main">
-  <p:cSld>
-    <p:bg>
-      <p:bgPr>
-        <a:solidFill>
-          <a:srgbClr val="FFFFFF"/>
-        </a:solidFill>
-      </p:bgPr>
-    </p:bg>
-    <p:spTree>
-      <p:nvGrpSpPr>
-        <p:cNvPr id="1" name=""/>
-        <p:cNvGrpSpPr/>
-        <p:nvPr/>
-      </p:nvGrpSpPr>
-      <p:grpSpPr>
-        <a:xfrm>
-          <a:off x="0" y="0"/>
-          <a:ext cx="0" cy="0"/>
-          <a:chOff x="0" y="0"/>
-          <a:chExt cx="0" cy="0"/>
-        </a:xfrm>
-      </p:grpSpPr>
-      <p:sp>
-        <p:nvSpPr>
-          <p:cNvPr id="2" name="Title Placeholder 1"/>
-          <p:cNvSpPr/>
-          <p:nvPr>
-            <p:ph type="title"/>
-          </p:nvPr>
-        </p:nvSpPr>
-        <p:spPr>
-          <a:xfrm>
-            <a:off x="812800" y="1153120"/>
-            <a:ext cx="10566400" cy="502841"/>
-          </a:xfrm>
-          <a:prstGeom prst="rect">
-            <a:avLst/>
-          </a:prstGeom>
-          <a:noFill/>
-          <a:ln/>
-        </p:spPr>
-        <p:txBody>
-          <a:bodyPr wrap="square" lIns="0" tIns="0" rIns="0" bIns="0" rtlCol="0" anchor="t"/>
-          <a:lstStyle>
-            <a:lvl1pPr algn="l" indent="0" marL="0">
-              <a:lnSpc>
-                <a:spcPct val="115000"/>
-              </a:lnSpc>
-              <a:buNone/>
-              <a:defRPr lang="en-US" sz="3600" dirty="0">
-                <a:solidFill>
-                  <a:srgbClr val="16191E"/>
-                </a:solidFill>
-                <a:latin typeface="Arial" pitchFamily="34" charset="0"/>
-                <a:ea typeface="Arial" pitchFamily="34" charset="-122"/>
-                <a:cs typeface="Arial" pitchFamily="34" charset="-120"/>
-              </a:defRPr>
-            </a:lvl1pPr>
-          </a:lstStyle>
-          <a:p>
-            <a:pPr algn="l" indent="0" marL="0">
-              <a:lnSpc>
-                <a:spcPct val="115000"/>
-              </a:lnSpc>
-              <a:buNone/>
-            </a:pPr>
-            <a:endParaRPr lang="en-US" sz="3600" dirty="0"/>
-          </a:p>
-        </p:txBody>
-      </p:sp>
-      <p:sp>
-        <p:nvSpPr>
-          <p:cNvPr id="3" name="Text Placeholder 2"/>
-          <p:cNvSpPr/>
-          <p:nvPr>
-            <p:ph idx="101" type="body"/>
-          </p:nvPr>
-        </p:nvSpPr>
-        <p:spPr>
-          <a:xfrm>
-            <a:off x="812800" y="1960761"/>
-            <a:ext cx="10566400" cy="4084439"/>
-          </a:xfrm>
-          <a:prstGeom prst="rect">
-            <a:avLst/>
-          </a:prstGeom>
-          <a:noFill/>
-          <a:ln/>
-        </p:spPr>
-        <p:txBody>
-          <a:bodyPr wrap="square" lIns="0" tIns="0" rIns="0" bIns="0" rtlCol="0" anchor="t"/>
-          <a:lstStyle>
-            <a:lvl1pPr algn="l" indent="0" marL="0">
-              <a:lnSpc>
-                <a:spcPct val="140000"/>
-              </a:lnSpc>
-              <a:buNone/>
-              <a:defRPr lang="en-US" sz="1600" dirty="0">
-                <a:solidFill>
-                  <a:srgbClr val="16191E"/>
-                </a:solidFill>
-                <a:latin typeface="Arial" pitchFamily="34" charset="0"/>
-                <a:ea typeface="Arial" pitchFamily="34" charset="-122"/>
-                <a:cs typeface="Arial" pitchFamily="34" charset="-120"/>
-              </a:defRPr>
-            </a:lvl1pPr>
-          </a:lstStyle>
-          <a:p>
-            <a:pPr algn="l" indent="0" marL="0">
-              <a:lnSpc>
-                <a:spcPct val="140000"/>
-              </a:lnSpc>
-              <a:buNone/>
-            </a:pPr>
-            <a:endParaRPr lang="en-US" sz="1600" dirty="0"/>
-          </a:p>
-        </p:txBody>
-      </p:sp>
     </p:spTree>
   </p:cSld>
   <p:clrMap bg1="lt1" tx1="dk1" bg2="lt2" tx2="dk2" accent1="accent1" accent2="accent2" accent3="accent3" accent4="accent4" accent5="accent5" accent6="accent6" hlink="hlink" folHlink="folHlink"/>
   <p:sldLayoutIdLst>
     <p:sldLayoutId id="2147483649" r:id="rId1"/>
-    <p:sldLayoutId id="2147483650" r:id="rId2"/>
   </p:sldLayoutIdLst>
   <p:hf sldNum="0" hdr="0" ftr="0" dt="0"/>
   <p:txStyles>
@@ -2252,9 +2020,7 @@
         <p:nvSpPr>
           <p:cNvPr id="5" name="Text 1"/>
           <p:cNvSpPr/>
-          <p:nvPr>
-            <p:ph type="title"/>
-          </p:nvPr>
+          <p:nvPr/>
         </p:nvSpPr>
         <p:spPr>
           <a:xfrm>
@@ -2280,13 +2046,13 @@
               <a:buNone/>
             </a:pPr>
             <a:r>
-              <a:rPr lang="en-US" sz="6000" b="1" i="0" spc="-100" kern="0" dirty="0">
+              <a:rPr lang="en-US" sz="6000" b="1" spc="-100" kern="0" dirty="0">
                 <a:solidFill>
                   <a:srgbClr val="16191E"/>
                 </a:solidFill>
-                <a:latin typeface="Arial" pitchFamily="34" charset="0"/>
-                <a:ea typeface="Arial" pitchFamily="34" charset="-122"/>
-                <a:cs typeface="Arial" pitchFamily="34" charset="-120"/>
+                <a:latin typeface="Inter" pitchFamily="34" charset="0"/>
+                <a:ea typeface="Inter" pitchFamily="34" charset="-122"/>
+                <a:cs typeface="Inter" pitchFamily="34" charset="-120"/>
               </a:rPr>
               <a:t>AgentRaaS</a:t>
             </a:r>
@@ -2328,9 +2094,9 @@
                 <a:solidFill>
                   <a:srgbClr val="4A5058"/>
                 </a:solidFill>
-                <a:latin typeface="Arial" pitchFamily="34" charset="0"/>
-                <a:ea typeface="Arial" pitchFamily="34" charset="-122"/>
-                <a:cs typeface="Arial" pitchFamily="34" charset="-120"/>
+                <a:latin typeface="Inter" pitchFamily="34" charset="0"/>
+                <a:ea typeface="Inter" pitchFamily="34" charset="-122"/>
+                <a:cs typeface="Inter" pitchFamily="34" charset="-120"/>
               </a:rPr>
               <a:t>The reliability layer for AI agents that take real actions: every call runs once, within the rules you set, risky calls wait for a human, and every action is on the record.</a:t>
             </a:r>
@@ -2372,9 +2138,9 @@
                 <a:solidFill>
                   <a:srgbClr val="6A7079"/>
                 </a:solidFill>
-                <a:latin typeface="Arial" pitchFamily="34" charset="0"/>
-                <a:ea typeface="Arial" pitchFamily="34" charset="-122"/>
-                <a:cs typeface="Arial" pitchFamily="34" charset="-120"/>
+                <a:latin typeface="Inter" pitchFamily="34" charset="0"/>
+                <a:ea typeface="Inter" pitchFamily="34" charset="-122"/>
+                <a:cs typeface="Inter" pitchFamily="34" charset="-120"/>
               </a:rPr>
               <a:t>agentraas.io</a:t>
             </a:r>
@@ -2448,9 +2214,9 @@
                 <a:solidFill>
                   <a:srgbClr val="9A6A08"/>
                 </a:solidFill>
-                <a:latin typeface="Arial" pitchFamily="34" charset="0"/>
-                <a:ea typeface="Arial" pitchFamily="34" charset="-122"/>
-                <a:cs typeface="Arial" pitchFamily="34" charset="-120"/>
+                <a:latin typeface="Inter" pitchFamily="34" charset="0"/>
+                <a:ea typeface="Inter" pitchFamily="34" charset="-122"/>
+                <a:cs typeface="Inter" pitchFamily="34" charset="-120"/>
               </a:rPr>
               <a:t>KEYS</a:t>
             </a:r>
@@ -2462,9 +2228,7 @@
         <p:nvSpPr>
           <p:cNvPr id="3" name="Text 1"/>
           <p:cNvSpPr/>
-          <p:nvPr>
-            <p:ph type="title"/>
-          </p:nvPr>
+          <p:nvPr/>
         </p:nvSpPr>
         <p:spPr>
           <a:xfrm>
@@ -2490,13 +2254,13 @@
               <a:buNone/>
             </a:pPr>
             <a:r>
-              <a:rPr lang="en-US" sz="3600" b="1" i="0" dirty="0">
+              <a:rPr lang="en-US" sz="3600" b="1" dirty="0">
                 <a:solidFill>
                   <a:srgbClr val="16191E"/>
                 </a:solidFill>
-                <a:latin typeface="Arial" pitchFamily="34" charset="0"/>
-                <a:ea typeface="Arial" pitchFamily="34" charset="-122"/>
-                <a:cs typeface="Arial" pitchFamily="34" charset="-120"/>
+                <a:latin typeface="Inter" pitchFamily="34" charset="0"/>
+                <a:ea typeface="Inter" pitchFamily="34" charset="-122"/>
+                <a:cs typeface="Inter" pitchFamily="34" charset="-120"/>
               </a:rPr>
               <a:t>Your API keys stay yours</a:t>
             </a:r>
@@ -2565,9 +2329,9 @@
                 <a:solidFill>
                   <a:srgbClr val="9A6A08"/>
                 </a:solidFill>
-                <a:latin typeface="Arial" pitchFamily="34" charset="0"/>
-                <a:ea typeface="Arial" pitchFamily="34" charset="-122"/>
-                <a:cs typeface="Arial" pitchFamily="34" charset="-120"/>
+                <a:latin typeface="Inter" pitchFamily="34" charset="0"/>
+                <a:ea typeface="Inter" pitchFamily="34" charset="-122"/>
+                <a:cs typeface="Inter" pitchFamily="34" charset="-120"/>
               </a:rPr>
               <a:t>Every install</a:t>
             </a:r>
@@ -2609,9 +2373,9 @@
                 <a:solidFill>
                   <a:srgbClr val="16191E"/>
                 </a:solidFill>
-                <a:latin typeface="Arial" pitchFamily="34" charset="0"/>
-                <a:ea typeface="Arial" pitchFamily="34" charset="-122"/>
-                <a:cs typeface="Arial" pitchFamily="34" charset="-120"/>
+                <a:latin typeface="Inter" pitchFamily="34" charset="0"/>
+                <a:ea typeface="Inter" pitchFamily="34" charset="-122"/>
+                <a:cs typeface="Inter" pitchFamily="34" charset="-120"/>
               </a:rPr>
               <a:t>Encrypted at rest</a:t>
             </a:r>
@@ -2653,9 +2417,9 @@
                 <a:solidFill>
                   <a:srgbClr val="4A5058"/>
                 </a:solidFill>
-                <a:latin typeface="Arial" pitchFamily="34" charset="0"/>
-                <a:ea typeface="Arial" pitchFamily="34" charset="-122"/>
-                <a:cs typeface="Arial" pitchFamily="34" charset="-120"/>
+                <a:latin typeface="Inter" pitchFamily="34" charset="0"/>
+                <a:ea typeface="Inter" pitchFamily="34" charset="-122"/>
+                <a:cs typeface="Inter" pitchFamily="34" charset="-120"/>
               </a:rPr>
               <a:t>Stripe, Slack and other keys are stored AES-256-GCM encrypted. Agents never see them: each agent holds only its own AgentRaaS key.</a:t>
             </a:r>
@@ -2724,9 +2488,9 @@
                 <a:solidFill>
                   <a:srgbClr val="9A6A08"/>
                 </a:solidFill>
-                <a:latin typeface="Arial" pitchFamily="34" charset="0"/>
-                <a:ea typeface="Arial" pitchFamily="34" charset="-122"/>
-                <a:cs typeface="Arial" pitchFamily="34" charset="-120"/>
+                <a:latin typeface="Inter" pitchFamily="34" charset="0"/>
+                <a:ea typeface="Inter" pitchFamily="34" charset="-122"/>
+                <a:cs typeface="Inter" pitchFamily="34" charset="-120"/>
               </a:rPr>
               <a:t>Self-hosted</a:t>
             </a:r>
@@ -2768,9 +2532,9 @@
                 <a:solidFill>
                   <a:srgbClr val="16191E"/>
                 </a:solidFill>
-                <a:latin typeface="Arial" pitchFamily="34" charset="0"/>
-                <a:ea typeface="Arial" pitchFamily="34" charset="-122"/>
-                <a:cs typeface="Arial" pitchFamily="34" charset="-120"/>
+                <a:latin typeface="Inter" pitchFamily="34" charset="0"/>
+                <a:ea typeface="Inter" pitchFamily="34" charset="-122"/>
+                <a:cs typeface="Inter" pitchFamily="34" charset="-120"/>
               </a:rPr>
               <a:t>Master key in your KMS</a:t>
             </a:r>
@@ -2812,9 +2576,9 @@
                 <a:solidFill>
                   <a:srgbClr val="4A5058"/>
                 </a:solidFill>
-                <a:latin typeface="Arial" pitchFamily="34" charset="0"/>
-                <a:ea typeface="Arial" pitchFamily="34" charset="-122"/>
-                <a:cs typeface="Arial" pitchFamily="34" charset="-120"/>
+                <a:latin typeface="Inter" pitchFamily="34" charset="0"/>
+                <a:ea typeface="Inter" pitchFamily="34" charset="-122"/>
+                <a:cs typeface="Inter" pitchFamily="34" charset="-120"/>
               </a:rPr>
               <a:t>Vault, AWS KMS, Google Cloud KMS or Azure Key Vault holds the key that unlocks them. A copied config file or backup is useless on its own.</a:t>
             </a:r>
@@ -2878,9 +2642,9 @@
                 <a:solidFill>
                   <a:srgbClr val="F2B544"/>
                 </a:solidFill>
-                <a:latin typeface="Arial" pitchFamily="34" charset="0"/>
-                <a:ea typeface="Arial" pitchFamily="34" charset="-122"/>
-                <a:cs typeface="Arial" pitchFamily="34" charset="-120"/>
+                <a:latin typeface="Inter" pitchFamily="34" charset="0"/>
+                <a:ea typeface="Inter" pitchFamily="34" charset="-122"/>
+                <a:cs typeface="Inter" pitchFamily="34" charset="-120"/>
               </a:rPr>
               <a:t>Self-hosted Enterprise</a:t>
             </a:r>
@@ -2922,9 +2686,9 @@
                 <a:solidFill>
                   <a:srgbClr val="ECEFF3"/>
                 </a:solidFill>
-                <a:latin typeface="Arial" pitchFamily="34" charset="0"/>
-                <a:ea typeface="Arial" pitchFamily="34" charset="-122"/>
-                <a:cs typeface="Arial" pitchFamily="34" charset="-120"/>
+                <a:latin typeface="Inter" pitchFamily="34" charset="0"/>
+                <a:ea typeface="Inter" pitchFamily="34" charset="-122"/>
+                <a:cs typeface="Inter" pitchFamily="34" charset="-120"/>
               </a:rPr>
               <a:t>Keys never stored</a:t>
             </a:r>
@@ -2966,9 +2730,9 @@
                 <a:solidFill>
                   <a:srgbClr val="B8C0CB"/>
                 </a:solidFill>
-                <a:latin typeface="Arial" pitchFamily="34" charset="0"/>
-                <a:ea typeface="Arial" pitchFamily="34" charset="-122"/>
-                <a:cs typeface="Arial" pitchFamily="34" charset="-120"/>
+                <a:latin typeface="Inter" pitchFamily="34" charset="0"/>
+                <a:ea typeface="Inter" pitchFamily="34" charset="-122"/>
+                <a:cs typeface="Inter" pitchFamily="34" charset="-120"/>
               </a:rPr>
               <a:t>Save a reference such as vault://secret/data/stripe instead of the key. It is fetched from your secrets manager when a call needs it, kept in memory for five minutes, never written down.</a:t>
             </a:r>
@@ -3010,9 +2774,9 @@
                 <a:solidFill>
                   <a:srgbClr val="6A7079"/>
                 </a:solidFill>
-                <a:latin typeface="Arial" pitchFamily="34" charset="0"/>
-                <a:ea typeface="Arial" pitchFamily="34" charset="-122"/>
-                <a:cs typeface="Arial" pitchFamily="34" charset="-120"/>
+                <a:latin typeface="Inter" pitchFamily="34" charset="0"/>
+                <a:ea typeface="Inter" pitchFamily="34" charset="-122"/>
+                <a:cs typeface="Inter" pitchFamily="34" charset="-120"/>
               </a:rPr>
               <a:t>Details: agentraas.io/docs#kms and agentraas.io/docs#secret-refs</a:t>
             </a:r>
@@ -3086,9 +2850,9 @@
                 <a:solidFill>
                   <a:srgbClr val="9A6A08"/>
                 </a:solidFill>
-                <a:latin typeface="Arial" pitchFamily="34" charset="0"/>
-                <a:ea typeface="Arial" pitchFamily="34" charset="-122"/>
-                <a:cs typeface="Arial" pitchFamily="34" charset="-120"/>
+                <a:latin typeface="Inter" pitchFamily="34" charset="0"/>
+                <a:ea typeface="Inter" pitchFamily="34" charset="-122"/>
+                <a:cs typeface="Inter" pitchFamily="34" charset="-120"/>
               </a:rPr>
               <a:t>OPEN SOURCE</a:t>
             </a:r>
@@ -3100,9 +2864,7 @@
         <p:nvSpPr>
           <p:cNvPr id="3" name="Text 1"/>
           <p:cNvSpPr/>
-          <p:nvPr>
-            <p:ph type="title"/>
-          </p:nvPr>
+          <p:nvPr/>
         </p:nvSpPr>
         <p:spPr>
           <a:xfrm>
@@ -3128,13 +2890,13 @@
               <a:buNone/>
             </a:pPr>
             <a:r>
-              <a:rPr lang="en-US" sz="3600" b="1" i="0" dirty="0">
+              <a:rPr lang="en-US" sz="3600" b="1" dirty="0">
                 <a:solidFill>
                   <a:srgbClr val="16191E"/>
                 </a:solidFill>
-                <a:latin typeface="Arial" pitchFamily="34" charset="0"/>
-                <a:ea typeface="Arial" pitchFamily="34" charset="-122"/>
-                <a:cs typeface="Arial" pitchFamily="34" charset="-120"/>
+                <a:latin typeface="Inter" pitchFamily="34" charset="0"/>
+                <a:ea typeface="Inter" pitchFamily="34" charset="-122"/>
+                <a:cs typeface="Inter" pitchFamily="34" charset="-120"/>
               </a:rPr>
               <a:t>Open source, free to self-host</a:t>
             </a:r>
@@ -3186,16 +2948,16 @@
                           <a:solidFill>
                             <a:srgbClr val="16191E"/>
                           </a:solidFill>
-                          <a:latin typeface="Arial" pitchFamily="34" charset="0"/>
-                          <a:ea typeface="Arial" pitchFamily="34" charset="-122"/>
-                          <a:cs typeface="Arial" pitchFamily="34" charset="-120"/>
+                          <a:latin typeface="Inter" pitchFamily="34" charset="0"/>
+                          <a:ea typeface="Inter" pitchFamily="34" charset="-122"/>
+                          <a:cs typeface="Inter" pitchFamily="34" charset="-120"/>
                         </a:rPr>
                         <a:t>Part</a:t>
                       </a:r>
                       <a:endParaRPr lang="en-US" sz="1200" dirty="0">
-                        <a:latin typeface="Arial" charset="0"/>
-                        <a:ea typeface="Arial" charset="0"/>
-                        <a:cs typeface="Arial" charset="0"/>
+                        <a:latin typeface="Inter" charset="0"/>
+                        <a:ea typeface="Inter" charset="0"/>
+                        <a:cs typeface="Inter" charset="0"/>
                       </a:endParaRPr>
                     </a:p>
                   </a:txBody>
@@ -3257,16 +3019,16 @@
                           <a:solidFill>
                             <a:srgbClr val="16191E"/>
                           </a:solidFill>
-                          <a:latin typeface="Arial" pitchFamily="34" charset="0"/>
-                          <a:ea typeface="Arial" pitchFamily="34" charset="-122"/>
-                          <a:cs typeface="Arial" pitchFamily="34" charset="-120"/>
+                          <a:latin typeface="Inter" pitchFamily="34" charset="0"/>
+                          <a:ea typeface="Inter" pitchFamily="34" charset="-122"/>
+                          <a:cs typeface="Inter" pitchFamily="34" charset="-120"/>
                         </a:rPr>
                         <a:t>License</a:t>
                       </a:r>
                       <a:endParaRPr lang="en-US" sz="1200" dirty="0">
-                        <a:latin typeface="Arial" charset="0"/>
-                        <a:ea typeface="Arial" charset="0"/>
-                        <a:cs typeface="Arial" charset="0"/>
+                        <a:latin typeface="Inter" charset="0"/>
+                        <a:ea typeface="Inter" charset="0"/>
+                        <a:cs typeface="Inter" charset="0"/>
                       </a:endParaRPr>
                     </a:p>
                   </a:txBody>
@@ -3328,16 +3090,16 @@
                           <a:solidFill>
                             <a:srgbClr val="16191E"/>
                           </a:solidFill>
-                          <a:latin typeface="Arial" pitchFamily="34" charset="0"/>
-                          <a:ea typeface="Arial" pitchFamily="34" charset="-122"/>
-                          <a:cs typeface="Arial" pitchFamily="34" charset="-120"/>
+                          <a:latin typeface="Inter" pitchFamily="34" charset="0"/>
+                          <a:ea typeface="Inter" pitchFamily="34" charset="-122"/>
+                          <a:cs typeface="Inter" pitchFamily="34" charset="-120"/>
                         </a:rPr>
                         <a:t>In plain words</a:t>
                       </a:r>
                       <a:endParaRPr lang="en-US" sz="1200" dirty="0">
-                        <a:latin typeface="Arial" charset="0"/>
-                        <a:ea typeface="Arial" charset="0"/>
-                        <a:cs typeface="Arial" charset="0"/>
+                        <a:latin typeface="Inter" charset="0"/>
+                        <a:ea typeface="Inter" charset="0"/>
+                        <a:cs typeface="Inter" charset="0"/>
                       </a:endParaRPr>
                     </a:p>
                   </a:txBody>
@@ -3401,16 +3163,16 @@
                           <a:solidFill>
                             <a:srgbClr val="16191E"/>
                           </a:solidFill>
-                          <a:latin typeface="Arial" pitchFamily="34" charset="0"/>
-                          <a:ea typeface="Arial" pitchFamily="34" charset="-122"/>
-                          <a:cs typeface="Arial" pitchFamily="34" charset="-120"/>
+                          <a:latin typeface="Inter" pitchFamily="34" charset="0"/>
+                          <a:ea typeface="Inter" pitchFamily="34" charset="-122"/>
+                          <a:cs typeface="Inter" pitchFamily="34" charset="-120"/>
                         </a:rPr>
                         <a:t>The server core</a:t>
                       </a:r>
                       <a:endParaRPr lang="en-US" sz="1200" dirty="0">
-                        <a:latin typeface="Arial" charset="0"/>
-                        <a:ea typeface="Arial" charset="0"/>
-                        <a:cs typeface="Arial" charset="0"/>
+                        <a:latin typeface="Inter" charset="0"/>
+                        <a:ea typeface="Inter" charset="0"/>
+                        <a:cs typeface="Inter" charset="0"/>
                       </a:endParaRPr>
                     </a:p>
                   </a:txBody>
@@ -3469,16 +3231,16 @@
                           <a:solidFill>
                             <a:srgbClr val="16191E"/>
                           </a:solidFill>
-                          <a:latin typeface="Arial" pitchFamily="34" charset="0"/>
-                          <a:ea typeface="Arial" pitchFamily="34" charset="-122"/>
-                          <a:cs typeface="Arial" pitchFamily="34" charset="-120"/>
+                          <a:latin typeface="Inter" pitchFamily="34" charset="0"/>
+                          <a:ea typeface="Inter" pitchFamily="34" charset="-122"/>
+                          <a:cs typeface="Inter" pitchFamily="34" charset="-120"/>
                         </a:rPr>
                         <a:t>MIT</a:t>
                       </a:r>
                       <a:endParaRPr lang="en-US" sz="1200" dirty="0">
-                        <a:latin typeface="Arial" charset="0"/>
-                        <a:ea typeface="Arial" charset="0"/>
-                        <a:cs typeface="Arial" charset="0"/>
+                        <a:latin typeface="Inter" charset="0"/>
+                        <a:ea typeface="Inter" charset="0"/>
+                        <a:cs typeface="Inter" charset="0"/>
                       </a:endParaRPr>
                     </a:p>
                   </a:txBody>
@@ -3537,16 +3299,16 @@
                           <a:solidFill>
                             <a:srgbClr val="4A5058"/>
                           </a:solidFill>
-                          <a:latin typeface="Arial" pitchFamily="34" charset="0"/>
-                          <a:ea typeface="Arial" pitchFamily="34" charset="-122"/>
-                          <a:cs typeface="Arial" pitchFamily="34" charset="-120"/>
+                          <a:latin typeface="Inter" pitchFamily="34" charset="0"/>
+                          <a:ea typeface="Inter" pitchFamily="34" charset="-122"/>
+                          <a:cs typeface="Inter" pitchFamily="34" charset="-120"/>
                         </a:rPr>
                         <a:t>Use, change, run, host and share it for anything. Keep the notice.</a:t>
                       </a:r>
                       <a:endParaRPr lang="en-US" sz="1200" dirty="0">
-                        <a:latin typeface="Arial" charset="0"/>
-                        <a:ea typeface="Arial" charset="0"/>
-                        <a:cs typeface="Arial" charset="0"/>
+                        <a:latin typeface="Inter" charset="0"/>
+                        <a:ea typeface="Inter" charset="0"/>
+                        <a:cs typeface="Inter" charset="0"/>
                       </a:endParaRPr>
                     </a:p>
                   </a:txBody>
@@ -3607,16 +3369,16 @@
                           <a:solidFill>
                             <a:srgbClr val="16191E"/>
                           </a:solidFill>
-                          <a:latin typeface="Arial" pitchFamily="34" charset="0"/>
-                          <a:ea typeface="Arial" pitchFamily="34" charset="-122"/>
-                          <a:cs typeface="Arial" pitchFamily="34" charset="-120"/>
+                          <a:latin typeface="Inter" pitchFamily="34" charset="0"/>
+                          <a:ea typeface="Inter" pitchFamily="34" charset="-122"/>
+                          <a:cs typeface="Inter" pitchFamily="34" charset="-120"/>
                         </a:rPr>
                         <a:t>Team and Enterprise features</a:t>
                       </a:r>
                       <a:endParaRPr lang="en-US" sz="1200" dirty="0">
-                        <a:latin typeface="Arial" charset="0"/>
-                        <a:ea typeface="Arial" charset="0"/>
-                        <a:cs typeface="Arial" charset="0"/>
+                        <a:latin typeface="Inter" charset="0"/>
+                        <a:ea typeface="Inter" charset="0"/>
+                        <a:cs typeface="Inter" charset="0"/>
                       </a:endParaRPr>
                     </a:p>
                   </a:txBody>
@@ -3675,16 +3437,16 @@
                           <a:solidFill>
                             <a:srgbClr val="16191E"/>
                           </a:solidFill>
-                          <a:latin typeface="Arial" pitchFamily="34" charset="0"/>
-                          <a:ea typeface="Arial" pitchFamily="34" charset="-122"/>
-                          <a:cs typeface="Arial" pitchFamily="34" charset="-120"/>
+                          <a:latin typeface="Inter" pitchFamily="34" charset="0"/>
+                          <a:ea typeface="Inter" pitchFamily="34" charset="-122"/>
+                          <a:cs typeface="Inter" pitchFamily="34" charset="-120"/>
                         </a:rPr>
                         <a:t>Enterprise License (source-available)</a:t>
                       </a:r>
                       <a:endParaRPr lang="en-US" sz="1200" dirty="0">
-                        <a:latin typeface="Arial" charset="0"/>
-                        <a:ea typeface="Arial" charset="0"/>
-                        <a:cs typeface="Arial" charset="0"/>
+                        <a:latin typeface="Inter" charset="0"/>
+                        <a:ea typeface="Inter" charset="0"/>
+                        <a:cs typeface="Inter" charset="0"/>
                       </a:endParaRPr>
                     </a:p>
                   </a:txBody>
@@ -3743,16 +3505,16 @@
                           <a:solidFill>
                             <a:srgbClr val="4A5058"/>
                           </a:solidFill>
-                          <a:latin typeface="Arial" pitchFamily="34" charset="0"/>
-                          <a:ea typeface="Arial" pitchFamily="34" charset="-122"/>
-                          <a:cs typeface="Arial" pitchFamily="34" charset="-120"/>
+                          <a:latin typeface="Inter" pitchFamily="34" charset="0"/>
+                          <a:ea typeface="Inter" pitchFamily="34" charset="-122"/>
+                          <a:cs typeface="Inter" pitchFamily="34" charset="-120"/>
                         </a:rPr>
                         <a:t>Team features are free in production on your own servers. Enterprise features need a license.</a:t>
                       </a:r>
                       <a:endParaRPr lang="en-US" sz="1200" dirty="0">
-                        <a:latin typeface="Arial" charset="0"/>
-                        <a:ea typeface="Arial" charset="0"/>
-                        <a:cs typeface="Arial" charset="0"/>
+                        <a:latin typeface="Inter" charset="0"/>
+                        <a:ea typeface="Inter" charset="0"/>
+                        <a:cs typeface="Inter" charset="0"/>
                       </a:endParaRPr>
                     </a:p>
                   </a:txBody>
@@ -3813,16 +3575,16 @@
                           <a:solidFill>
                             <a:srgbClr val="16191E"/>
                           </a:solidFill>
-                          <a:latin typeface="Arial" pitchFamily="34" charset="0"/>
-                          <a:ea typeface="Arial" pitchFamily="34" charset="-122"/>
-                          <a:cs typeface="Arial" pitchFamily="34" charset="-120"/>
+                          <a:latin typeface="Inter" pitchFamily="34" charset="0"/>
+                          <a:ea typeface="Inter" pitchFamily="34" charset="-122"/>
+                          <a:cs typeface="Inter" pitchFamily="34" charset="-120"/>
                         </a:rPr>
                         <a:t>SDKs and tools</a:t>
                       </a:r>
                       <a:endParaRPr lang="en-US" sz="1200" dirty="0">
-                        <a:latin typeface="Arial" charset="0"/>
-                        <a:ea typeface="Arial" charset="0"/>
-                        <a:cs typeface="Arial" charset="0"/>
+                        <a:latin typeface="Inter" charset="0"/>
+                        <a:ea typeface="Inter" charset="0"/>
+                        <a:cs typeface="Inter" charset="0"/>
                       </a:endParaRPr>
                     </a:p>
                   </a:txBody>
@@ -3881,16 +3643,16 @@
                           <a:solidFill>
                             <a:srgbClr val="16191E"/>
                           </a:solidFill>
-                          <a:latin typeface="Arial" pitchFamily="34" charset="0"/>
-                          <a:ea typeface="Arial" pitchFamily="34" charset="-122"/>
-                          <a:cs typeface="Arial" pitchFamily="34" charset="-120"/>
+                          <a:latin typeface="Inter" pitchFamily="34" charset="0"/>
+                          <a:ea typeface="Inter" pitchFamily="34" charset="-122"/>
+                          <a:cs typeface="Inter" pitchFamily="34" charset="-120"/>
                         </a:rPr>
                         <a:t>MIT</a:t>
                       </a:r>
                       <a:endParaRPr lang="en-US" sz="1200" dirty="0">
-                        <a:latin typeface="Arial" charset="0"/>
-                        <a:ea typeface="Arial" charset="0"/>
-                        <a:cs typeface="Arial" charset="0"/>
+                        <a:latin typeface="Inter" charset="0"/>
+                        <a:ea typeface="Inter" charset="0"/>
+                        <a:cs typeface="Inter" charset="0"/>
                       </a:endParaRPr>
                     </a:p>
                   </a:txBody>
@@ -3949,16 +3711,16 @@
                           <a:solidFill>
                             <a:srgbClr val="4A5058"/>
                           </a:solidFill>
-                          <a:latin typeface="Arial" pitchFamily="34" charset="0"/>
-                          <a:ea typeface="Arial" pitchFamily="34" charset="-122"/>
-                          <a:cs typeface="Arial" pitchFamily="34" charset="-120"/>
+                          <a:latin typeface="Inter" pitchFamily="34" charset="0"/>
+                          <a:ea typeface="Inter" pitchFamily="34" charset="-122"/>
+                          <a:cs typeface="Inter" pitchFamily="34" charset="-120"/>
                         </a:rPr>
                         <a:t>No conditions beyond keeping the notice.</a:t>
                       </a:r>
                       <a:endParaRPr lang="en-US" sz="1200" dirty="0">
-                        <a:latin typeface="Arial" charset="0"/>
-                        <a:ea typeface="Arial" charset="0"/>
-                        <a:cs typeface="Arial" charset="0"/>
+                        <a:latin typeface="Inter" charset="0"/>
+                        <a:ea typeface="Inter" charset="0"/>
+                        <a:cs typeface="Inter" charset="0"/>
                       </a:endParaRPr>
                     </a:p>
                   </a:txBody>
@@ -4040,9 +3802,9 @@
                 <a:solidFill>
                   <a:srgbClr val="16191E"/>
                 </a:solidFill>
-                <a:latin typeface="Arial" pitchFamily="34" charset="0"/>
-                <a:ea typeface="Arial" pitchFamily="34" charset="-122"/>
-                <a:cs typeface="Arial" pitchFamily="34" charset="-120"/>
+                <a:latin typeface="Inter" pitchFamily="34" charset="0"/>
+                <a:ea typeface="Inter" pitchFamily="34" charset="-122"/>
+                <a:cs typeface="Inter" pitchFamily="34" charset="-120"/>
               </a:rPr>
               <a:t>Self-hosting needs no license key and has no action limit, approvals and SSO included.</a:t>
             </a:r>
@@ -4084,9 +3846,9 @@
                 <a:solidFill>
                   <a:srgbClr val="6A7079"/>
                 </a:solidFill>
-                <a:latin typeface="Arial" pitchFamily="34" charset="0"/>
-                <a:ea typeface="Arial" pitchFamily="34" charset="-122"/>
-                <a:cs typeface="Arial" pitchFamily="34" charset="-120"/>
+                <a:latin typeface="Inter" pitchFamily="34" charset="0"/>
+                <a:ea typeface="Inter" pitchFamily="34" charset="-122"/>
+                <a:cs typeface="Inter" pitchFamily="34" charset="-120"/>
               </a:rPr>
               <a:t>Details: LICENSE.md in github.com/agentraas/agentraas</a:t>
             </a:r>
@@ -4160,9 +3922,9 @@
                 <a:solidFill>
                   <a:srgbClr val="9A6A08"/>
                 </a:solidFill>
-                <a:latin typeface="Arial" pitchFamily="34" charset="0"/>
-                <a:ea typeface="Arial" pitchFamily="34" charset="-122"/>
-                <a:cs typeface="Arial" pitchFamily="34" charset="-120"/>
+                <a:latin typeface="Inter" pitchFamily="34" charset="0"/>
+                <a:ea typeface="Inter" pitchFamily="34" charset="-122"/>
+                <a:cs typeface="Inter" pitchFamily="34" charset="-120"/>
               </a:rPr>
               <a:t>AVAILABLE TODAY</a:t>
             </a:r>
@@ -4174,9 +3936,7 @@
         <p:nvSpPr>
           <p:cNvPr id="3" name="Text 1"/>
           <p:cNvSpPr/>
-          <p:nvPr>
-            <p:ph type="title"/>
-          </p:nvPr>
+          <p:nvPr/>
         </p:nvSpPr>
         <p:spPr>
           <a:xfrm>
@@ -4202,13 +3962,13 @@
               <a:buNone/>
             </a:pPr>
             <a:r>
-              <a:rPr lang="en-US" sz="3600" b="1" i="0" dirty="0">
+              <a:rPr lang="en-US" sz="3600" b="1" dirty="0">
                 <a:solidFill>
                   <a:srgbClr val="16191E"/>
                 </a:solidFill>
-                <a:latin typeface="Arial" pitchFamily="34" charset="0"/>
-                <a:ea typeface="Arial" pitchFamily="34" charset="-122"/>
-                <a:cs typeface="Arial" pitchFamily="34" charset="-120"/>
+                <a:latin typeface="Inter" pitchFamily="34" charset="0"/>
+                <a:ea typeface="Inter" pitchFamily="34" charset="-122"/>
+                <a:cs typeface="Inter" pitchFamily="34" charset="-120"/>
               </a:rPr>
               <a:t>Built, live and ready to try</a:t>
             </a:r>
@@ -4277,9 +4037,9 @@
                 <a:solidFill>
                   <a:srgbClr val="16191E"/>
                 </a:solidFill>
-                <a:latin typeface="Arial" pitchFamily="34" charset="0"/>
-                <a:ea typeface="Arial" pitchFamily="34" charset="-122"/>
-                <a:cs typeface="Arial" pitchFamily="34" charset="-120"/>
+                <a:latin typeface="Inter" pitchFamily="34" charset="0"/>
+                <a:ea typeface="Inter" pitchFamily="34" charset="-122"/>
+                <a:cs typeface="Inter" pitchFamily="34" charset="-120"/>
               </a:rPr>
               <a:t>What you get</a:t>
             </a:r>
@@ -4310,7 +4070,7 @@
           </a:bodyPr>
           <a:lstStyle/>
           <a:p>
-            <a:pPr algn="l" marL="182880" indent="-142494">
+            <a:pPr algn="l" marL="182880" indent="-148844">
               <a:lnSpc>
                 <a:spcPts val="1920"/>
               </a:lnSpc>
@@ -4322,16 +4082,16 @@
                 <a:solidFill>
                   <a:srgbClr val="4A5058"/>
                 </a:solidFill>
-                <a:latin typeface="Arial" pitchFamily="34" charset="0"/>
-                <a:ea typeface="Arial" pitchFamily="34" charset="-122"/>
-                <a:cs typeface="Arial" pitchFamily="34" charset="-120"/>
+                <a:latin typeface="Inter" pitchFamily="34" charset="0"/>
+                <a:ea typeface="Inter" pitchFamily="34" charset="-122"/>
+                <a:cs typeface="Inter" pitchFamily="34" charset="-120"/>
               </a:rPr>
               <a:t>A Rust gateway running in production</a:t>
             </a:r>
             <a:endParaRPr lang="en-US" sz="1200" dirty="0"/>
           </a:p>
           <a:p>
-            <a:pPr algn="l" marL="182880" indent="-142494">
+            <a:pPr algn="l" marL="182880" indent="-148844">
               <a:lnSpc>
                 <a:spcPts val="1920"/>
               </a:lnSpc>
@@ -4343,16 +4103,16 @@
                 <a:solidFill>
                   <a:srgbClr val="4A5058"/>
                 </a:solidFill>
-                <a:latin typeface="Arial" pitchFamily="34" charset="0"/>
-                <a:ea typeface="Arial" pitchFamily="34" charset="-122"/>
-                <a:cs typeface="Arial" pitchFamily="34" charset="-120"/>
-              </a:rPr>
-              <a:t>31 services ready to connect: paste a key, copy a URL</a:t>
+                <a:latin typeface="Inter" pitchFamily="34" charset="0"/>
+                <a:ea typeface="Inter" pitchFamily="34" charset="-122"/>
+                <a:cs typeface="Inter" pitchFamily="34" charset="-120"/>
+              </a:rPr>
+              <a:t>37 services ready to connect: paste a key, copy a URL</a:t>
             </a:r>
             <a:endParaRPr lang="en-US" sz="1200" dirty="0"/>
           </a:p>
           <a:p>
-            <a:pPr algn="l" marL="182880" indent="-142494">
+            <a:pPr algn="l" marL="182880" indent="-148844">
               <a:lnSpc>
                 <a:spcPts val="1920"/>
               </a:lnSpc>
@@ -4364,16 +4124,16 @@
                 <a:solidFill>
                   <a:srgbClr val="4A5058"/>
                 </a:solidFill>
-                <a:latin typeface="Arial" pitchFamily="34" charset="0"/>
-                <a:ea typeface="Arial" pitchFamily="34" charset="-122"/>
-                <a:cs typeface="Arial" pitchFamily="34" charset="-120"/>
+                <a:latin typeface="Inter" pitchFamily="34" charset="0"/>
+                <a:ea typeface="Inter" pitchFamily="34" charset="-122"/>
+                <a:cs typeface="Inter" pitchFamily="34" charset="-120"/>
               </a:rPr>
               <a:t>Python SDK on PyPI, TypeScript SDK on npm</a:t>
             </a:r>
             <a:endParaRPr lang="en-US" sz="1200" dirty="0"/>
           </a:p>
           <a:p>
-            <a:pPr algn="l" marL="182880" indent="-142494">
+            <a:pPr algn="l" marL="182880" indent="-148844">
               <a:lnSpc>
                 <a:spcPts val="1920"/>
               </a:lnSpc>
@@ -4385,16 +4145,16 @@
                 <a:solidFill>
                   <a:srgbClr val="4A5058"/>
                 </a:solidFill>
-                <a:latin typeface="Arial" pitchFamily="34" charset="0"/>
-                <a:ea typeface="Arial" pitchFamily="34" charset="-122"/>
-                <a:cs typeface="Arial" pitchFamily="34" charset="-120"/>
+                <a:latin typeface="Inter" pitchFamily="34" charset="0"/>
+                <a:ea typeface="Inter" pitchFamily="34" charset="-122"/>
+                <a:cs typeface="Inter" pitchFamily="34" charset="-120"/>
               </a:rPr>
               <a:t>Webhook, SDK and MCP integration</a:t>
             </a:r>
             <a:endParaRPr lang="en-US" sz="1200" dirty="0"/>
           </a:p>
           <a:p>
-            <a:pPr algn="l" marL="182880" indent="-142494">
+            <a:pPr algn="l" marL="182880" indent="-148844">
               <a:lnSpc>
                 <a:spcPts val="1920"/>
               </a:lnSpc>
@@ -4406,16 +4166,16 @@
                 <a:solidFill>
                   <a:srgbClr val="4A5058"/>
                 </a:solidFill>
-                <a:latin typeface="Arial" pitchFamily="34" charset="0"/>
-                <a:ea typeface="Arial" pitchFamily="34" charset="-122"/>
-                <a:cs typeface="Arial" pitchFamily="34" charset="-120"/>
+                <a:latin typeface="Inter" pitchFamily="34" charset="0"/>
+                <a:ea typeface="Inter" pitchFamily="34" charset="-122"/>
+                <a:cs typeface="Inter" pitchFamily="34" charset="-120"/>
               </a:rPr>
               <a:t>Open source (MIT core), free to self-host on Linux, macOS or Windows</a:t>
             </a:r>
             <a:endParaRPr lang="en-US" sz="1200" dirty="0"/>
           </a:p>
           <a:p>
-            <a:pPr algn="l" marL="182880" indent="-142494">
+            <a:pPr algn="l" marL="182880" indent="-148844">
               <a:lnSpc>
                 <a:spcPts val="1920"/>
               </a:lnSpc>
@@ -4427,11 +4187,11 @@
                 <a:solidFill>
                   <a:srgbClr val="4A5058"/>
                 </a:solidFill>
-                <a:latin typeface="Arial" pitchFamily="34" charset="0"/>
-                <a:ea typeface="Arial" pitchFamily="34" charset="-122"/>
-                <a:cs typeface="Arial" pitchFamily="34" charset="-120"/>
-              </a:rPr>
-              <a:t>Helm chart, rules as code in Git</a:t>
+                <a:latin typeface="Inter" pitchFamily="34" charset="0"/>
+                <a:ea typeface="Inter" pitchFamily="34" charset="-122"/>
+                <a:cs typeface="Inter" pitchFamily="34" charset="-120"/>
+              </a:rPr>
+              <a:t>Helm chart, Terraform for AWS, Azure and Google Cloud</a:t>
             </a:r>
             <a:endParaRPr lang="en-US" sz="1200" dirty="0"/>
           </a:p>
@@ -4493,9 +4253,9 @@
                 <a:solidFill>
                   <a:srgbClr val="F2B544"/>
                 </a:solidFill>
-                <a:latin typeface="Arial" pitchFamily="34" charset="0"/>
-                <a:ea typeface="Arial" pitchFamily="34" charset="-122"/>
-                <a:cs typeface="Arial" pitchFamily="34" charset="-120"/>
+                <a:latin typeface="Inter" pitchFamily="34" charset="0"/>
+                <a:ea typeface="Inter" pitchFamily="34" charset="-122"/>
+                <a:cs typeface="Inter" pitchFamily="34" charset="-120"/>
               </a:rPr>
               <a:t>Where to find it</a:t>
             </a:r>
@@ -4526,7 +4286,7 @@
           </a:bodyPr>
           <a:lstStyle/>
           <a:p>
-            <a:pPr algn="l" marL="182880" indent="-142494">
+            <a:pPr algn="l" marL="182880" indent="-148844">
               <a:lnSpc>
                 <a:spcPts val="1920"/>
               </a:lnSpc>
@@ -4538,16 +4298,16 @@
                 <a:solidFill>
                   <a:srgbClr val="ECEFF3"/>
                 </a:solidFill>
-                <a:latin typeface="Arial" pitchFamily="34" charset="0"/>
-                <a:ea typeface="Arial" pitchFamily="34" charset="-122"/>
-                <a:cs typeface="Arial" pitchFamily="34" charset="-120"/>
+                <a:latin typeface="Inter" pitchFamily="34" charset="0"/>
+                <a:ea typeface="Inter" pitchFamily="34" charset="-122"/>
+                <a:cs typeface="Inter" pitchFamily="34" charset="-120"/>
               </a:rPr>
               <a:t>Live demo, no signup: agentraas.io</a:t>
             </a:r>
             <a:endParaRPr lang="en-US" sz="1200" dirty="0"/>
           </a:p>
           <a:p>
-            <a:pPr algn="l" marL="182880" indent="-142494">
+            <a:pPr algn="l" marL="182880" indent="-148844">
               <a:lnSpc>
                 <a:spcPts val="1920"/>
               </a:lnSpc>
@@ -4559,16 +4319,16 @@
                 <a:solidFill>
                   <a:srgbClr val="ECEFF3"/>
                 </a:solidFill>
-                <a:latin typeface="Arial" pitchFamily="34" charset="0"/>
-                <a:ea typeface="Arial" pitchFamily="34" charset="-122"/>
-                <a:cs typeface="Arial" pitchFamily="34" charset="-120"/>
+                <a:latin typeface="Inter" pitchFamily="34" charset="0"/>
+                <a:ea typeface="Inter" pitchFamily="34" charset="-122"/>
+                <a:cs typeface="Inter" pitchFamily="34" charset="-120"/>
               </a:rPr>
               <a:t>Docs: agentraas.io/docs</a:t>
             </a:r>
             <a:endParaRPr lang="en-US" sz="1200" dirty="0"/>
           </a:p>
           <a:p>
-            <a:pPr algn="l" marL="182880" indent="-142494">
+            <a:pPr algn="l" marL="182880" indent="-148844">
               <a:lnSpc>
                 <a:spcPts val="1920"/>
               </a:lnSpc>
@@ -4580,16 +4340,16 @@
                 <a:solidFill>
                   <a:srgbClr val="ECEFF3"/>
                 </a:solidFill>
-                <a:latin typeface="Arial" pitchFamily="34" charset="0"/>
-                <a:ea typeface="Arial" pitchFamily="34" charset="-122"/>
-                <a:cs typeface="Arial" pitchFamily="34" charset="-120"/>
+                <a:latin typeface="Inter" pitchFamily="34" charset="0"/>
+                <a:ea typeface="Inter" pitchFamily="34" charset="-122"/>
+                <a:cs typeface="Inter" pitchFamily="34" charset="-120"/>
               </a:rPr>
               <a:t>Install: pip install agentraas</a:t>
             </a:r>
             <a:endParaRPr lang="en-US" sz="1200" dirty="0"/>
           </a:p>
           <a:p>
-            <a:pPr algn="l" marL="182880" indent="-142494">
+            <a:pPr algn="l" marL="182880" indent="-148844">
               <a:lnSpc>
                 <a:spcPts val="1920"/>
               </a:lnSpc>
@@ -4601,16 +4361,16 @@
                 <a:solidFill>
                   <a:srgbClr val="ECEFF3"/>
                 </a:solidFill>
-                <a:latin typeface="Arial" pitchFamily="34" charset="0"/>
-                <a:ea typeface="Arial" pitchFamily="34" charset="-122"/>
-                <a:cs typeface="Arial" pitchFamily="34" charset="-120"/>
+                <a:latin typeface="Inter" pitchFamily="34" charset="0"/>
+                <a:ea typeface="Inter" pitchFamily="34" charset="-122"/>
+                <a:cs typeface="Inter" pitchFamily="34" charset="-120"/>
               </a:rPr>
               <a:t>Or: npm install agentraas</a:t>
             </a:r>
             <a:endParaRPr lang="en-US" sz="1200" dirty="0"/>
           </a:p>
           <a:p>
-            <a:pPr algn="l" marL="182880" indent="-142494">
+            <a:pPr algn="l" marL="182880" indent="-148844">
               <a:lnSpc>
                 <a:spcPts val="1920"/>
               </a:lnSpc>
@@ -4622,16 +4382,16 @@
                 <a:solidFill>
                   <a:srgbClr val="ECEFF3"/>
                 </a:solidFill>
-                <a:latin typeface="Arial" pitchFamily="34" charset="0"/>
-                <a:ea typeface="Arial" pitchFamily="34" charset="-122"/>
-                <a:cs typeface="Arial" pitchFamily="34" charset="-120"/>
+                <a:latin typeface="Inter" pitchFamily="34" charset="0"/>
+                <a:ea typeface="Inter" pitchFamily="34" charset="-122"/>
+                <a:cs typeface="Inter" pitchFamily="34" charset="-120"/>
               </a:rPr>
               <a:t>Source: github.com/agentraas/agentraas</a:t>
             </a:r>
             <a:endParaRPr lang="en-US" sz="1200" dirty="0"/>
           </a:p>
           <a:p>
-            <a:pPr algn="l" marL="182880" indent="-142494">
+            <a:pPr algn="l" marL="182880" indent="-148844">
               <a:lnSpc>
                 <a:spcPts val="1920"/>
               </a:lnSpc>
@@ -4643,9 +4403,9 @@
                 <a:solidFill>
                   <a:srgbClr val="ECEFF3"/>
                 </a:solidFill>
-                <a:latin typeface="Arial" pitchFamily="34" charset="0"/>
-                <a:ea typeface="Arial" pitchFamily="34" charset="-122"/>
-                <a:cs typeface="Arial" pitchFamily="34" charset="-120"/>
+                <a:latin typeface="Inter" pitchFamily="34" charset="0"/>
+                <a:ea typeface="Inter" pitchFamily="34" charset="-122"/>
+                <a:cs typeface="Inter" pitchFamily="34" charset="-120"/>
               </a:rPr>
               <a:t>Official MCP Registry: io.github.agentraas/agentraas</a:t>
             </a:r>
@@ -4762,9 +4522,7 @@
         <p:nvSpPr>
           <p:cNvPr id="5" name="Text 1"/>
           <p:cNvSpPr/>
-          <p:nvPr>
-            <p:ph type="title"/>
-          </p:nvPr>
+          <p:nvPr/>
         </p:nvSpPr>
         <p:spPr>
           <a:xfrm>
@@ -4790,13 +4548,13 @@
               <a:buNone/>
             </a:pPr>
             <a:r>
-              <a:rPr lang="en-US" sz="4800" b="1" i="0" spc="-100" kern="0" dirty="0">
+              <a:rPr lang="en-US" sz="4800" b="1" spc="-100" kern="0" dirty="0">
                 <a:solidFill>
                   <a:srgbClr val="16191E"/>
                 </a:solidFill>
-                <a:latin typeface="Arial" pitchFamily="34" charset="0"/>
-                <a:ea typeface="Arial" pitchFamily="34" charset="-122"/>
-                <a:cs typeface="Arial" pitchFamily="34" charset="-120"/>
+                <a:latin typeface="Inter" pitchFamily="34" charset="0"/>
+                <a:ea typeface="Inter" pitchFamily="34" charset="-122"/>
+                <a:cs typeface="Inter" pitchFamily="34" charset="-120"/>
               </a:rPr>
               <a:t>Try it on your agent, free</a:t>
             </a:r>
@@ -4838,9 +4596,9 @@
                 <a:solidFill>
                   <a:srgbClr val="4A5058"/>
                 </a:solidFill>
-                <a:latin typeface="Arial" pitchFamily="34" charset="0"/>
-                <a:ea typeface="Arial" pitchFamily="34" charset="-122"/>
-                <a:cs typeface="Arial" pitchFamily="34" charset="-120"/>
+                <a:latin typeface="Inter" pitchFamily="34" charset="0"/>
+                <a:ea typeface="Inter" pitchFamily="34" charset="-122"/>
+                <a:cs typeface="Inter" pitchFamily="34" charset="-120"/>
               </a:rPr>
               <a:t>See it live, no signup: </a:t>
             </a:r>
@@ -4849,9 +4607,9 @@
                 <a:solidFill>
                   <a:srgbClr val="9A6A08"/>
                 </a:solidFill>
-                <a:latin typeface="Arial" pitchFamily="34" charset="0"/>
-                <a:ea typeface="Arial" pitchFamily="34" charset="-122"/>
-                <a:cs typeface="Arial" pitchFamily="34" charset="-120"/>
+                <a:latin typeface="Inter" pitchFamily="34" charset="0"/>
+                <a:ea typeface="Inter" pitchFamily="34" charset="-122"/>
+                <a:cs typeface="Inter" pitchFamily="34" charset="-120"/>
               </a:rPr>
               <a:t>agentraas.io</a:t>
             </a:r>
@@ -4893,9 +4651,9 @@
                 <a:solidFill>
                   <a:srgbClr val="4A5058"/>
                 </a:solidFill>
-                <a:latin typeface="Arial" pitchFamily="34" charset="0"/>
-                <a:ea typeface="Arial" pitchFamily="34" charset="-122"/>
-                <a:cs typeface="Arial" pitchFamily="34" charset="-120"/>
+                <a:latin typeface="Inter" pitchFamily="34" charset="0"/>
+                <a:ea typeface="Inter" pitchFamily="34" charset="-122"/>
+                <a:cs typeface="Inter" pitchFamily="34" charset="-120"/>
               </a:rPr>
               <a:t>Find duplicate calls: </a:t>
             </a:r>
@@ -4904,9 +4662,9 @@
                 <a:solidFill>
                   <a:srgbClr val="9A6A08"/>
                 </a:solidFill>
-                <a:latin typeface="Arial" pitchFamily="34" charset="0"/>
-                <a:ea typeface="Arial" pitchFamily="34" charset="-122"/>
-                <a:cs typeface="Arial" pitchFamily="34" charset="-120"/>
+                <a:latin typeface="Inter" pitchFamily="34" charset="0"/>
+                <a:ea typeface="Inter" pitchFamily="34" charset="-122"/>
+                <a:cs typeface="Inter" pitchFamily="34" charset="-120"/>
               </a:rPr>
               <a:t>agentraas chaos</a:t>
             </a:r>
@@ -4948,9 +4706,9 @@
                 <a:solidFill>
                   <a:srgbClr val="4A5058"/>
                 </a:solidFill>
-                <a:latin typeface="Arial" pitchFamily="34" charset="0"/>
-                <a:ea typeface="Arial" pitchFamily="34" charset="-122"/>
-                <a:cs typeface="Arial" pitchFamily="34" charset="-120"/>
+                <a:latin typeface="Inter" pitchFamily="34" charset="0"/>
+                <a:ea typeface="Inter" pitchFamily="34" charset="-122"/>
+                <a:cs typeface="Inter" pitchFamily="34" charset="-120"/>
               </a:rPr>
               <a:t>Install: </a:t>
             </a:r>
@@ -4959,9 +4717,9 @@
                 <a:solidFill>
                   <a:srgbClr val="9A6A08"/>
                 </a:solidFill>
-                <a:latin typeface="Arial" pitchFamily="34" charset="0"/>
-                <a:ea typeface="Arial" pitchFamily="34" charset="-122"/>
-                <a:cs typeface="Arial" pitchFamily="34" charset="-120"/>
+                <a:latin typeface="Inter" pitchFamily="34" charset="0"/>
+                <a:ea typeface="Inter" pitchFamily="34" charset="-122"/>
+                <a:cs typeface="Inter" pitchFamily="34" charset="-120"/>
               </a:rPr>
               <a:t>pip or npm install agentraas</a:t>
             </a:r>
@@ -5003,9 +4761,9 @@
                 <a:solidFill>
                   <a:srgbClr val="4A5058"/>
                 </a:solidFill>
-                <a:latin typeface="Arial" pitchFamily="34" charset="0"/>
-                <a:ea typeface="Arial" pitchFamily="34" charset="-122"/>
-                <a:cs typeface="Arial" pitchFamily="34" charset="-120"/>
+                <a:latin typeface="Inter" pitchFamily="34" charset="0"/>
+                <a:ea typeface="Inter" pitchFamily="34" charset="-122"/>
+                <a:cs typeface="Inter" pitchFamily="34" charset="-120"/>
               </a:rPr>
               <a:t>Self-host free: </a:t>
             </a:r>
@@ -5014,9 +4772,9 @@
                 <a:solidFill>
                   <a:srgbClr val="9A6A08"/>
                 </a:solidFill>
-                <a:latin typeface="Arial" pitchFamily="34" charset="0"/>
-                <a:ea typeface="Arial" pitchFamily="34" charset="-122"/>
-                <a:cs typeface="Arial" pitchFamily="34" charset="-120"/>
+                <a:latin typeface="Inter" pitchFamily="34" charset="0"/>
+                <a:ea typeface="Inter" pitchFamily="34" charset="-122"/>
+                <a:cs typeface="Inter" pitchFamily="34" charset="-120"/>
               </a:rPr>
               <a:t>agentraas.io/self-host</a:t>
             </a:r>
@@ -5055,8 +4813,8 @@
         </p:nvSpPr>
         <p:spPr>
           <a:xfrm>
-            <a:off x="8046452" y="4902200"/>
-            <a:ext cx="1077397" cy="238720"/>
+            <a:off x="8033703" y="4902200"/>
+            <a:ext cx="1102995" cy="238720"/>
           </a:xfrm>
           <a:prstGeom prst="rect">
             <a:avLst/>
@@ -5081,9 +4839,9 @@
                 <a:solidFill>
                   <a:srgbClr val="4A5058"/>
                 </a:solidFill>
-                <a:latin typeface="Arial" pitchFamily="34" charset="0"/>
-                <a:ea typeface="Arial" pitchFamily="34" charset="-122"/>
-                <a:cs typeface="Arial" pitchFamily="34" charset="-120"/>
+                <a:latin typeface="Inter" pitchFamily="34" charset="0"/>
+                <a:ea typeface="Inter" pitchFamily="34" charset="-122"/>
+                <a:cs typeface="Inter" pitchFamily="34" charset="-120"/>
               </a:rPr>
               <a:t>agentraas.io</a:t>
             </a:r>
@@ -5122,8 +4880,8 @@
         </p:nvSpPr>
         <p:spPr>
           <a:xfrm>
-            <a:off x="10312410" y="4902200"/>
-            <a:ext cx="609481" cy="238720"/>
+            <a:off x="10310981" y="4902200"/>
+            <a:ext cx="612338" cy="238720"/>
           </a:xfrm>
           <a:prstGeom prst="rect">
             <a:avLst/>
@@ -5148,9 +4906,9 @@
                 <a:solidFill>
                   <a:srgbClr val="4A5058"/>
                 </a:solidFill>
-                <a:latin typeface="Arial" pitchFamily="34" charset="0"/>
-                <a:ea typeface="Arial" pitchFamily="34" charset="-122"/>
-                <a:cs typeface="Arial" pitchFamily="34" charset="-120"/>
+                <a:latin typeface="Inter" pitchFamily="34" charset="0"/>
+                <a:ea typeface="Inter" pitchFamily="34" charset="-122"/>
+                <a:cs typeface="Inter" pitchFamily="34" charset="-120"/>
               </a:rPr>
               <a:t>GitHub</a:t>
             </a:r>
@@ -5192,9 +4950,9 @@
                 <a:solidFill>
                   <a:srgbClr val="6A7079"/>
                 </a:solidFill>
-                <a:latin typeface="Arial" pitchFamily="34" charset="0"/>
-                <a:ea typeface="Arial" pitchFamily="34" charset="-122"/>
-                <a:cs typeface="Arial" pitchFamily="34" charset="-120"/>
+                <a:latin typeface="Inter" pitchFamily="34" charset="0"/>
+                <a:ea typeface="Inter" pitchFamily="34" charset="-122"/>
+                <a:cs typeface="Inter" pitchFamily="34" charset="-120"/>
               </a:rPr>
               <a:t>agentraas.io · hello@agentraas.io · github.com/agentraas/agentraas</a:t>
             </a:r>
@@ -5268,9 +5026,9 @@
                 <a:solidFill>
                   <a:srgbClr val="9A6A08"/>
                 </a:solidFill>
-                <a:latin typeface="Arial" pitchFamily="34" charset="0"/>
-                <a:ea typeface="Arial" pitchFamily="34" charset="-122"/>
-                <a:cs typeface="Arial" pitchFamily="34" charset="-120"/>
+                <a:latin typeface="Inter" pitchFamily="34" charset="0"/>
+                <a:ea typeface="Inter" pitchFamily="34" charset="-122"/>
+                <a:cs typeface="Inter" pitchFamily="34" charset="-120"/>
               </a:rPr>
               <a:t>THE PROBLEM</a:t>
             </a:r>
@@ -5282,9 +5040,7 @@
         <p:nvSpPr>
           <p:cNvPr id="3" name="Text 1"/>
           <p:cNvSpPr/>
-          <p:nvPr>
-            <p:ph type="title"/>
-          </p:nvPr>
+          <p:nvPr/>
         </p:nvSpPr>
         <p:spPr>
           <a:xfrm>
@@ -5310,13 +5066,13 @@
               <a:buNone/>
             </a:pPr>
             <a:r>
-              <a:rPr lang="en-US" sz="3600" b="1" i="0" dirty="0">
+              <a:rPr lang="en-US" sz="3600" b="1" dirty="0">
                 <a:solidFill>
                   <a:srgbClr val="16191E"/>
                 </a:solidFill>
-                <a:latin typeface="Arial" pitchFamily="34" charset="0"/>
-                <a:ea typeface="Arial" pitchFamily="34" charset="-122"/>
-                <a:cs typeface="Arial" pitchFamily="34" charset="-120"/>
+                <a:latin typeface="Inter" pitchFamily="34" charset="0"/>
+                <a:ea typeface="Inter" pitchFamily="34" charset="-122"/>
+                <a:cs typeface="Inter" pitchFamily="34" charset="-120"/>
               </a:rPr>
               <a:t>A retry can become a second charge</a:t>
             </a:r>
@@ -5385,9 +5141,9 @@
                 <a:solidFill>
                   <a:srgbClr val="9A6A08"/>
                 </a:solidFill>
-                <a:latin typeface="Arial" pitchFamily="34" charset="0"/>
-                <a:ea typeface="Arial" pitchFamily="34" charset="-122"/>
-                <a:cs typeface="Arial" pitchFamily="34" charset="-120"/>
+                <a:latin typeface="Inter" pitchFamily="34" charset="0"/>
+                <a:ea typeface="Inter" pitchFamily="34" charset="-122"/>
+                <a:cs typeface="Inter" pitchFamily="34" charset="-120"/>
               </a:rPr>
               <a:t>1</a:t>
             </a:r>
@@ -5429,9 +5185,9 @@
                 <a:solidFill>
                   <a:srgbClr val="16191E"/>
                 </a:solidFill>
-                <a:latin typeface="Arial" pitchFamily="34" charset="0"/>
-                <a:ea typeface="Arial" pitchFamily="34" charset="-122"/>
-                <a:cs typeface="Arial" pitchFamily="34" charset="-120"/>
+                <a:latin typeface="Inter" pitchFamily="34" charset="0"/>
+                <a:ea typeface="Inter" pitchFamily="34" charset="-122"/>
+                <a:cs typeface="Inter" pitchFamily="34" charset="-120"/>
               </a:rPr>
               <a:t>The API call succeeds</a:t>
             </a:r>
@@ -5473,9 +5229,9 @@
                 <a:solidFill>
                   <a:srgbClr val="4A5058"/>
                 </a:solidFill>
-                <a:latin typeface="Arial" pitchFamily="34" charset="0"/>
-                <a:ea typeface="Arial" pitchFamily="34" charset="-122"/>
-                <a:cs typeface="Arial" pitchFamily="34" charset="-120"/>
+                <a:latin typeface="Inter" pitchFamily="34" charset="0"/>
+                <a:ea typeface="Inter" pitchFamily="34" charset="-122"/>
+                <a:cs typeface="Inter" pitchFamily="34" charset="-120"/>
               </a:rPr>
               <a:t>Stripe charges the card. The response is on its way back.</a:t>
             </a:r>
@@ -5567,9 +5323,9 @@
                 <a:solidFill>
                   <a:srgbClr val="9A6A08"/>
                 </a:solidFill>
-                <a:latin typeface="Arial" pitchFamily="34" charset="0"/>
-                <a:ea typeface="Arial" pitchFamily="34" charset="-122"/>
-                <a:cs typeface="Arial" pitchFamily="34" charset="-120"/>
+                <a:latin typeface="Inter" pitchFamily="34" charset="0"/>
+                <a:ea typeface="Inter" pitchFamily="34" charset="-122"/>
+                <a:cs typeface="Inter" pitchFamily="34" charset="-120"/>
               </a:rPr>
               <a:t>2</a:t>
             </a:r>
@@ -5611,9 +5367,9 @@
                 <a:solidFill>
                   <a:srgbClr val="16191E"/>
                 </a:solidFill>
-                <a:latin typeface="Arial" pitchFamily="34" charset="0"/>
-                <a:ea typeface="Arial" pitchFamily="34" charset="-122"/>
-                <a:cs typeface="Arial" pitchFamily="34" charset="-120"/>
+                <a:latin typeface="Inter" pitchFamily="34" charset="0"/>
+                <a:ea typeface="Inter" pitchFamily="34" charset="-122"/>
+                <a:cs typeface="Inter" pitchFamily="34" charset="-120"/>
               </a:rPr>
               <a:t>The response is lost</a:t>
             </a:r>
@@ -5655,9 +5411,9 @@
                 <a:solidFill>
                   <a:srgbClr val="4A5058"/>
                 </a:solidFill>
-                <a:latin typeface="Arial" pitchFamily="34" charset="0"/>
-                <a:ea typeface="Arial" pitchFamily="34" charset="-122"/>
-                <a:cs typeface="Arial" pitchFamily="34" charset="-120"/>
+                <a:latin typeface="Inter" pitchFamily="34" charset="0"/>
+                <a:ea typeface="Inter" pitchFamily="34" charset="-122"/>
+                <a:cs typeface="Inter" pitchFamily="34" charset="-120"/>
               </a:rPr>
               <a:t>A timeout, a dropped connection, a crashed worker.</a:t>
             </a:r>
@@ -5744,9 +5500,9 @@
                 <a:solidFill>
                   <a:srgbClr val="F2B544"/>
                 </a:solidFill>
-                <a:latin typeface="Arial" pitchFamily="34" charset="0"/>
-                <a:ea typeface="Arial" pitchFamily="34" charset="-122"/>
-                <a:cs typeface="Arial" pitchFamily="34" charset="-120"/>
+                <a:latin typeface="Inter" pitchFamily="34" charset="0"/>
+                <a:ea typeface="Inter" pitchFamily="34" charset="-122"/>
+                <a:cs typeface="Inter" pitchFamily="34" charset="-120"/>
               </a:rPr>
               <a:t>3</a:t>
             </a:r>
@@ -5788,9 +5544,9 @@
                 <a:solidFill>
                   <a:srgbClr val="ECEFF3"/>
                 </a:solidFill>
-                <a:latin typeface="Arial" pitchFamily="34" charset="0"/>
-                <a:ea typeface="Arial" pitchFamily="34" charset="-122"/>
-                <a:cs typeface="Arial" pitchFamily="34" charset="-120"/>
+                <a:latin typeface="Inter" pitchFamily="34" charset="0"/>
+                <a:ea typeface="Inter" pitchFamily="34" charset="-122"/>
+                <a:cs typeface="Inter" pitchFamily="34" charset="-120"/>
               </a:rPr>
               <a:t>The agent retries</a:t>
             </a:r>
@@ -5832,9 +5588,9 @@
                 <a:solidFill>
                   <a:srgbClr val="B8C0CB"/>
                 </a:solidFill>
-                <a:latin typeface="Arial" pitchFamily="34" charset="0"/>
-                <a:ea typeface="Arial" pitchFamily="34" charset="-122"/>
-                <a:cs typeface="Arial" pitchFamily="34" charset="-120"/>
+                <a:latin typeface="Inter" pitchFamily="34" charset="0"/>
+                <a:ea typeface="Inter" pitchFamily="34" charset="-122"/>
+                <a:cs typeface="Inter" pitchFamily="34" charset="-120"/>
               </a:rPr>
               <a:t>The card is charged twice. The customer finds out first.</a:t>
             </a:r>
@@ -5876,9 +5632,9 @@
                 <a:solidFill>
                   <a:srgbClr val="4A5058"/>
                 </a:solidFill>
-                <a:latin typeface="Arial" pitchFamily="34" charset="0"/>
-                <a:ea typeface="Arial" pitchFamily="34" charset="-122"/>
-                <a:cs typeface="Arial" pitchFamily="34" charset="-120"/>
+                <a:latin typeface="Inter" pitchFamily="34" charset="0"/>
+                <a:ea typeface="Inter" pitchFamily="34" charset="-122"/>
+                <a:cs typeface="Inter" pitchFamily="34" charset="-120"/>
               </a:rPr>
               <a:t>The most common failure, not the only one: agents also act outside their remit (a prompt-injected email to a stranger), loop on the same call, and leave no record anyone can audit.</a:t>
             </a:r>
@@ -5952,9 +5708,9 @@
                 <a:solidFill>
                   <a:srgbClr val="9A6A08"/>
                 </a:solidFill>
-                <a:latin typeface="Arial" pitchFamily="34" charset="0"/>
-                <a:ea typeface="Arial" pitchFamily="34" charset="-122"/>
-                <a:cs typeface="Arial" pitchFamily="34" charset="-120"/>
+                <a:latin typeface="Inter" pitchFamily="34" charset="0"/>
+                <a:ea typeface="Inter" pitchFamily="34" charset="-122"/>
+                <a:cs typeface="Inter" pitchFamily="34" charset="-120"/>
               </a:rPr>
               <a:t>WHY NOW</a:t>
             </a:r>
@@ -5966,14 +5722,12 @@
         <p:nvSpPr>
           <p:cNvPr id="3" name="Text 1"/>
           <p:cNvSpPr/>
-          <p:nvPr>
-            <p:ph type="title"/>
-          </p:nvPr>
+          <p:nvPr/>
         </p:nvSpPr>
         <p:spPr>
           <a:xfrm>
             <a:off x="812800" y="1153120"/>
-            <a:ext cx="10883392" cy="528241"/>
+            <a:ext cx="11379200" cy="528241"/>
           </a:xfrm>
           <a:prstGeom prst="rect">
             <a:avLst/>
@@ -5994,13 +5748,13 @@
               <a:buNone/>
             </a:pPr>
             <a:r>
-              <a:rPr lang="en-US" sz="3600" b="1" i="0" dirty="0">
+              <a:rPr lang="en-US" sz="3600" b="1" dirty="0">
                 <a:solidFill>
                   <a:srgbClr val="16191E"/>
                 </a:solidFill>
-                <a:latin typeface="Arial" pitchFamily="34" charset="0"/>
-                <a:ea typeface="Arial" pitchFamily="34" charset="-122"/>
-                <a:cs typeface="Arial" pitchFamily="34" charset="-120"/>
+                <a:latin typeface="Inter" pitchFamily="34" charset="0"/>
+                <a:ea typeface="Inter" pitchFamily="34" charset="-122"/>
+                <a:cs typeface="Inter" pitchFamily="34" charset="-120"/>
               </a:rPr>
               <a:t>Agents have started acting, not just answering</a:t>
             </a:r>
@@ -6092,9 +5846,9 @@
                 <a:solidFill>
                   <a:srgbClr val="16191E"/>
                 </a:solidFill>
-                <a:latin typeface="Arial" pitchFamily="34" charset="0"/>
-                <a:ea typeface="Arial" pitchFamily="34" charset="-122"/>
-                <a:cs typeface="Arial" pitchFamily="34" charset="-120"/>
+                <a:latin typeface="Inter" pitchFamily="34" charset="0"/>
+                <a:ea typeface="Inter" pitchFamily="34" charset="-122"/>
+                <a:cs typeface="Inter" pitchFamily="34" charset="-120"/>
               </a:rPr>
               <a:t>Tools gave agents hands</a:t>
             </a:r>
@@ -6136,9 +5890,9 @@
                 <a:solidFill>
                   <a:srgbClr val="4A5058"/>
                 </a:solidFill>
-                <a:latin typeface="Arial" pitchFamily="34" charset="0"/>
-                <a:ea typeface="Arial" pitchFamily="34" charset="-122"/>
-                <a:cs typeface="Arial" pitchFamily="34" charset="-120"/>
+                <a:latin typeface="Inter" pitchFamily="34" charset="0"/>
+                <a:ea typeface="Inter" pitchFamily="34" charset="-122"/>
+                <a:cs typeface="Inter" pitchFamily="34" charset="-120"/>
               </a:rPr>
               <a:t>Through tool calling and MCP, agents now move money, send email, update CRMs and file tickets on their own.</a:t>
             </a:r>
@@ -6230,9 +5984,9 @@
                 <a:solidFill>
                   <a:srgbClr val="16191E"/>
                 </a:solidFill>
-                <a:latin typeface="Arial" pitchFamily="34" charset="0"/>
-                <a:ea typeface="Arial" pitchFamily="34" charset="-122"/>
-                <a:cs typeface="Arial" pitchFamily="34" charset="-120"/>
+                <a:latin typeface="Inter" pitchFamily="34" charset="0"/>
+                <a:ea typeface="Inter" pitchFamily="34" charset="-122"/>
+                <a:cs typeface="Inter" pitchFamily="34" charset="-120"/>
               </a:rPr>
               <a:t>Retries are built in</a:t>
             </a:r>
@@ -6249,7 +6003,7 @@
         <p:spPr>
           <a:xfrm>
             <a:off x="4667250" y="3074491"/>
-            <a:ext cx="2956306" cy="711200"/>
+            <a:ext cx="2956306" cy="939800"/>
           </a:xfrm>
           <a:prstGeom prst="rect">
             <a:avLst/>
@@ -6274,9 +6028,9 @@
                 <a:solidFill>
                   <a:srgbClr val="4A5058"/>
                 </a:solidFill>
-                <a:latin typeface="Arial" pitchFamily="34" charset="0"/>
-                <a:ea typeface="Arial" pitchFamily="34" charset="-122"/>
-                <a:cs typeface="Arial" pitchFamily="34" charset="-120"/>
+                <a:latin typeface="Inter" pitchFamily="34" charset="0"/>
+                <a:ea typeface="Inter" pitchFamily="34" charset="-122"/>
+                <a:cs typeface="Inter" pitchFamily="34" charset="-120"/>
               </a:rPr>
               <a:t>Frameworks, queues and HTTP clients retry automatically, so duplicate actions are the default failure, not an edge case.</a:t>
             </a:r>
@@ -6363,9 +6117,9 @@
                 <a:solidFill>
                   <a:srgbClr val="ECEFF3"/>
                 </a:solidFill>
-                <a:latin typeface="Arial" pitchFamily="34" charset="0"/>
-                <a:ea typeface="Arial" pitchFamily="34" charset="-122"/>
-                <a:cs typeface="Arial" pitchFamily="34" charset="-120"/>
+                <a:latin typeface="Inter" pitchFamily="34" charset="0"/>
+                <a:ea typeface="Inter" pitchFamily="34" charset="-122"/>
+                <a:cs typeface="Inter" pitchFamily="34" charset="-120"/>
               </a:rPr>
               <a:t>Every team rebuilds it</a:t>
             </a:r>
@@ -6382,7 +6136,7 @@
         <p:spPr>
           <a:xfrm>
             <a:off x="8255000" y="3068141"/>
-            <a:ext cx="2956306" cy="711200"/>
+            <a:ext cx="2956306" cy="939800"/>
           </a:xfrm>
           <a:prstGeom prst="rect">
             <a:avLst/>
@@ -6407,9 +6161,9 @@
                 <a:solidFill>
                   <a:srgbClr val="B8C0CB"/>
                 </a:solidFill>
-                <a:latin typeface="Arial" pitchFamily="34" charset="0"/>
-                <a:ea typeface="Arial" pitchFamily="34" charset="-122"/>
-                <a:cs typeface="Arial" pitchFamily="34" charset="-120"/>
+                <a:latin typeface="Inter" pitchFamily="34" charset="0"/>
+                <a:ea typeface="Inter" pitchFamily="34" charset="-122"/>
+                <a:cs typeface="Inter" pitchFamily="34" charset="-120"/>
               </a:rPr>
               <a:t>Idempotency, approval steps and action logs get hand-built per agent, per API. There is no shared layer for it yet.</a:t>
             </a:r>
@@ -6483,9 +6237,9 @@
                 <a:solidFill>
                   <a:srgbClr val="9A6A08"/>
                 </a:solidFill>
-                <a:latin typeface="Arial" pitchFamily="34" charset="0"/>
-                <a:ea typeface="Arial" pitchFamily="34" charset="-122"/>
-                <a:cs typeface="Arial" pitchFamily="34" charset="-120"/>
+                <a:latin typeface="Inter" pitchFamily="34" charset="0"/>
+                <a:ea typeface="Inter" pitchFamily="34" charset="-122"/>
+                <a:cs typeface="Inter" pitchFamily="34" charset="-120"/>
               </a:rPr>
               <a:t>WHAT WE OFFER</a:t>
             </a:r>
@@ -6497,9 +6251,7 @@
         <p:nvSpPr>
           <p:cNvPr id="3" name="Text 1"/>
           <p:cNvSpPr/>
-          <p:nvPr>
-            <p:ph type="title"/>
-          </p:nvPr>
+          <p:nvPr/>
         </p:nvSpPr>
         <p:spPr>
           <a:xfrm>
@@ -6525,13 +6277,13 @@
               <a:buNone/>
             </a:pPr>
             <a:r>
-              <a:rPr lang="en-US" sz="3600" b="1" i="0" dirty="0">
+              <a:rPr lang="en-US" sz="3600" b="1" dirty="0">
                 <a:solidFill>
                   <a:srgbClr val="16191E"/>
                 </a:solidFill>
-                <a:latin typeface="Arial" pitchFamily="34" charset="0"/>
-                <a:ea typeface="Arial" pitchFamily="34" charset="-122"/>
-                <a:cs typeface="Arial" pitchFamily="34" charset="-120"/>
+                <a:latin typeface="Inter" pitchFamily="34" charset="0"/>
+                <a:ea typeface="Inter" pitchFamily="34" charset="-122"/>
+                <a:cs typeface="Inter" pitchFamily="34" charset="-120"/>
               </a:rPr>
               <a:t>Six controls in one layer</a:t>
             </a:r>
@@ -6548,11 +6300,11 @@
         <p:spPr>
           <a:xfrm>
             <a:off x="815975" y="1963936"/>
-            <a:ext cx="3397250" cy="1946970"/>
+            <a:ext cx="3397250" cy="2057400"/>
           </a:xfrm>
           <a:prstGeom prst="roundRect">
             <a:avLst>
-              <a:gd name="adj" fmla="val 6360"/>
+              <a:gd name="adj" fmla="val 6019"/>
             </a:avLst>
           </a:prstGeom>
           <a:solidFill>
@@ -6598,7 +6350,7 @@
         <p:spPr>
           <a:xfrm>
             <a:off x="1403350" y="2200771"/>
-            <a:ext cx="1246465" cy="269180"/>
+            <a:ext cx="1248132" cy="269180"/>
           </a:xfrm>
           <a:prstGeom prst="rect">
             <a:avLst/>
@@ -6623,9 +6375,9 @@
                 <a:solidFill>
                   <a:srgbClr val="16191E"/>
                 </a:solidFill>
-                <a:latin typeface="Arial" pitchFamily="34" charset="0"/>
-                <a:ea typeface="Arial" pitchFamily="34" charset="-122"/>
-                <a:cs typeface="Arial" pitchFamily="34" charset="-120"/>
+                <a:latin typeface="Inter" pitchFamily="34" charset="0"/>
+                <a:ea typeface="Inter" pitchFamily="34" charset="-122"/>
+                <a:cs typeface="Inter" pitchFamily="34" charset="-120"/>
               </a:rPr>
               <a:t>Runs once</a:t>
             </a:r>
@@ -6642,7 +6394,7 @@
         <p:spPr>
           <a:xfrm>
             <a:off x="1047750" y="2538611"/>
-            <a:ext cx="3021711" cy="688280"/>
+            <a:ext cx="3021711" cy="909241"/>
           </a:xfrm>
           <a:prstGeom prst="rect">
             <a:avLst/>
@@ -6667,11 +6419,11 @@
                 <a:solidFill>
                   <a:srgbClr val="4A5058"/>
                 </a:solidFill>
-                <a:latin typeface="Arial" pitchFamily="34" charset="0"/>
-                <a:ea typeface="Arial" pitchFamily="34" charset="-122"/>
-                <a:cs typeface="Arial" pitchFamily="34" charset="-120"/>
-              </a:rPr>
-              <a:t>Atomic dedup, near-duplicate matching, and step checkpoints so a failed run resumes, not repeats.</a:t>
+                <a:latin typeface="Inter" pitchFamily="34" charset="0"/>
+                <a:ea typeface="Inter" pitchFamily="34" charset="-122"/>
+                <a:cs typeface="Inter" pitchFamily="34" charset="-120"/>
+              </a:rPr>
+              <a:t>Atomic dedup, near-duplicate matching, step checkpoints, and record locks so two agents never change one customer at once.</a:t>
             </a:r>
             <a:endParaRPr lang="en-US" sz="1200" dirty="0"/>
           </a:p>
@@ -6686,11 +6438,11 @@
         <p:spPr>
           <a:xfrm>
             <a:off x="4397375" y="1963936"/>
-            <a:ext cx="3397250" cy="1946970"/>
+            <a:ext cx="3397250" cy="2057400"/>
           </a:xfrm>
           <a:prstGeom prst="roundRect">
             <a:avLst>
-              <a:gd name="adj" fmla="val 6360"/>
+              <a:gd name="adj" fmla="val 6019"/>
             </a:avLst>
           </a:prstGeom>
           <a:solidFill>
@@ -6736,7 +6488,7 @@
         <p:spPr>
           <a:xfrm>
             <a:off x="4984750" y="2200771"/>
-            <a:ext cx="1910477" cy="269180"/>
+            <a:ext cx="1946791" cy="269180"/>
           </a:xfrm>
           <a:prstGeom prst="rect">
             <a:avLst/>
@@ -6761,9 +6513,9 @@
                 <a:solidFill>
                   <a:srgbClr val="16191E"/>
                 </a:solidFill>
-                <a:latin typeface="Arial" pitchFamily="34" charset="0"/>
-                <a:ea typeface="Arial" pitchFamily="34" charset="-122"/>
-                <a:cs typeface="Arial" pitchFamily="34" charset="-120"/>
+                <a:latin typeface="Inter" pitchFamily="34" charset="0"/>
+                <a:ea typeface="Inter" pitchFamily="34" charset="-122"/>
+                <a:cs typeface="Inter" pitchFamily="34" charset="-120"/>
               </a:rPr>
               <a:t>Human approval</a:t>
             </a:r>
@@ -6805,9 +6557,9 @@
                 <a:solidFill>
                   <a:srgbClr val="4A5058"/>
                 </a:solidFill>
-                <a:latin typeface="Arial" pitchFamily="34" charset="0"/>
-                <a:ea typeface="Arial" pitchFamily="34" charset="-122"/>
-                <a:cs typeface="Arial" pitchFamily="34" charset="-120"/>
+                <a:latin typeface="Inter" pitchFamily="34" charset="0"/>
+                <a:ea typeface="Inter" pitchFamily="34" charset="-122"/>
+                <a:cs typeface="Inter" pitchFamily="34" charset="-120"/>
               </a:rPr>
               <a:t>Risky calls wait for a person to approve in Slack, Teams, Telegram, Discord, email or the dashboard.</a:t>
             </a:r>
@@ -6824,11 +6576,11 @@
         <p:spPr>
           <a:xfrm>
             <a:off x="7978775" y="1963936"/>
-            <a:ext cx="3397250" cy="1946970"/>
+            <a:ext cx="3397250" cy="2057400"/>
           </a:xfrm>
           <a:prstGeom prst="roundRect">
             <a:avLst>
-              <a:gd name="adj" fmla="val 6360"/>
+              <a:gd name="adj" fmla="val 6019"/>
             </a:avLst>
           </a:prstGeom>
           <a:solidFill>
@@ -6874,7 +6626,7 @@
         <p:spPr>
           <a:xfrm>
             <a:off x="8566150" y="2200771"/>
-            <a:ext cx="2127528" cy="269180"/>
+            <a:ext cx="2137172" cy="269180"/>
           </a:xfrm>
           <a:prstGeom prst="rect">
             <a:avLst/>
@@ -6899,9 +6651,9 @@
                 <a:solidFill>
                   <a:srgbClr val="16191E"/>
                 </a:solidFill>
-                <a:latin typeface="Arial" pitchFamily="34" charset="0"/>
-                <a:ea typeface="Arial" pitchFamily="34" charset="-122"/>
-                <a:cs typeface="Arial" pitchFamily="34" charset="-120"/>
+                <a:latin typeface="Inter" pitchFamily="34" charset="0"/>
+                <a:ea typeface="Inter" pitchFamily="34" charset="-122"/>
+                <a:cs typeface="Inter" pitchFamily="34" charset="-120"/>
               </a:rPr>
               <a:t>Policies and limits</a:t>
             </a:r>
@@ -6943,9 +6695,9 @@
                 <a:solidFill>
                   <a:srgbClr val="4A5058"/>
                 </a:solidFill>
-                <a:latin typeface="Arial" pitchFamily="34" charset="0"/>
-                <a:ea typeface="Arial" pitchFamily="34" charset="-122"/>
-                <a:cs typeface="Arial" pitchFamily="34" charset="-120"/>
+                <a:latin typeface="Inter" pitchFamily="34" charset="0"/>
+                <a:ea typeface="Inter" pitchFamily="34" charset="-122"/>
+                <a:cs typeface="Inter" pitchFamily="34" charset="-120"/>
               </a:rPr>
               <a:t>What each agent may do, daily money caps, allowed hours, call caps and loop limits.</a:t>
             </a:r>
@@ -6961,12 +6713,12 @@
         </p:nvSpPr>
         <p:spPr>
           <a:xfrm>
-            <a:off x="815975" y="4095055"/>
-            <a:ext cx="3397250" cy="1946970"/>
+            <a:off x="815975" y="4205486"/>
+            <a:ext cx="3397250" cy="1836539"/>
           </a:xfrm>
           <a:prstGeom prst="roundRect">
             <a:avLst>
-              <a:gd name="adj" fmla="val 6360"/>
+              <a:gd name="adj" fmla="val 6742"/>
             </a:avLst>
           </a:prstGeom>
           <a:solidFill>
@@ -6995,7 +6747,7 @@
         </p:blipFill>
         <p:spPr>
           <a:xfrm>
-            <a:off x="1047750" y="4326830"/>
+            <a:off x="1047750" y="4437261"/>
             <a:ext cx="254000" cy="254000"/>
           </a:xfrm>
           <a:prstGeom prst="rect">
@@ -7011,8 +6763,8 @@
         </p:nvSpPr>
         <p:spPr>
           <a:xfrm>
-            <a:off x="1403350" y="4331891"/>
-            <a:ext cx="1206341" cy="269180"/>
+            <a:off x="1403350" y="4442321"/>
+            <a:ext cx="1223486" cy="269180"/>
           </a:xfrm>
           <a:prstGeom prst="rect">
             <a:avLst/>
@@ -7037,9 +6789,9 @@
                 <a:solidFill>
                   <a:srgbClr val="16191E"/>
                 </a:solidFill>
-                <a:latin typeface="Arial" pitchFamily="34" charset="0"/>
-                <a:ea typeface="Arial" pitchFamily="34" charset="-122"/>
-                <a:cs typeface="Arial" pitchFamily="34" charset="-120"/>
+                <a:latin typeface="Inter" pitchFamily="34" charset="0"/>
+                <a:ea typeface="Inter" pitchFamily="34" charset="-122"/>
+                <a:cs typeface="Inter" pitchFamily="34" charset="-120"/>
               </a:rPr>
               <a:t>Resilience</a:t>
             </a:r>
@@ -7055,7 +6807,7 @@
         </p:nvSpPr>
         <p:spPr>
           <a:xfrm>
-            <a:off x="1047750" y="4669730"/>
+            <a:off x="1047750" y="4780161"/>
             <a:ext cx="3021711" cy="688280"/>
           </a:xfrm>
           <a:prstGeom prst="rect">
@@ -7081,9 +6833,9 @@
                 <a:solidFill>
                   <a:srgbClr val="4A5058"/>
                 </a:solidFill>
-                <a:latin typeface="Arial" pitchFamily="34" charset="0"/>
-                <a:ea typeface="Arial" pitchFamily="34" charset="-122"/>
-                <a:cs typeface="Arial" pitchFamily="34" charset="-120"/>
+                <a:latin typeface="Inter" pitchFamily="34" charset="0"/>
+                <a:ea typeface="Inter" pitchFamily="34" charset="-122"/>
+                <a:cs typeface="Inter" pitchFamily="34" charset="-120"/>
               </a:rPr>
               <a:t>Circuit breaking, safe retries, a replayable dead-letter queue, and one-click undo of a charge or message.</a:t>
             </a:r>
@@ -7099,12 +6851,12 @@
         </p:nvSpPr>
         <p:spPr>
           <a:xfrm>
-            <a:off x="4397375" y="4095055"/>
-            <a:ext cx="3397250" cy="1946970"/>
+            <a:off x="4397375" y="4205486"/>
+            <a:ext cx="3397250" cy="1836539"/>
           </a:xfrm>
           <a:prstGeom prst="roundRect">
             <a:avLst>
-              <a:gd name="adj" fmla="val 6360"/>
+              <a:gd name="adj" fmla="val 6742"/>
             </a:avLst>
           </a:prstGeom>
           <a:solidFill>
@@ -7133,7 +6885,7 @@
         </p:blipFill>
         <p:spPr>
           <a:xfrm>
-            <a:off x="4629150" y="4326830"/>
+            <a:off x="4629150" y="4437261"/>
             <a:ext cx="254000" cy="254000"/>
           </a:xfrm>
           <a:prstGeom prst="rect">
@@ -7149,8 +6901,8 @@
         </p:nvSpPr>
         <p:spPr>
           <a:xfrm>
-            <a:off x="4984750" y="4331891"/>
-            <a:ext cx="2058948" cy="269180"/>
+            <a:off x="4984750" y="4442321"/>
+            <a:ext cx="2119670" cy="269180"/>
           </a:xfrm>
           <a:prstGeom prst="rect">
             <a:avLst/>
@@ -7175,9 +6927,9 @@
                 <a:solidFill>
                   <a:srgbClr val="16191E"/>
                 </a:solidFill>
-                <a:latin typeface="Arial" pitchFamily="34" charset="0"/>
-                <a:ea typeface="Arial" pitchFamily="34" charset="-122"/>
-                <a:cs typeface="Arial" pitchFamily="34" charset="-120"/>
+                <a:latin typeface="Inter" pitchFamily="34" charset="0"/>
+                <a:ea typeface="Inter" pitchFamily="34" charset="-122"/>
+                <a:cs typeface="Inter" pitchFamily="34" charset="-120"/>
               </a:rPr>
               <a:t>Audit and identity</a:t>
             </a:r>
@@ -7193,7 +6945,7 @@
         </p:nvSpPr>
         <p:spPr>
           <a:xfrm>
-            <a:off x="4629150" y="4669730"/>
+            <a:off x="4629150" y="4780161"/>
             <a:ext cx="3021711" cy="688280"/>
           </a:xfrm>
           <a:prstGeom prst="rect">
@@ -7219,11 +6971,11 @@
                 <a:solidFill>
                   <a:srgbClr val="4A5058"/>
                 </a:solidFill>
-                <a:latin typeface="Arial" pitchFamily="34" charset="0"/>
-                <a:ea typeface="Arial" pitchFamily="34" charset="-122"/>
-                <a:cs typeface="Arial" pitchFamily="34" charset="-120"/>
-              </a:rPr>
-              <a:t>Tamper-evident logs, OpenTelemetry export, scoped agent identities, and record and replay for testing.</a:t>
+                <a:latin typeface="Inter" pitchFamily="34" charset="0"/>
+                <a:ea typeface="Inter" pitchFamily="34" charset="-122"/>
+                <a:cs typeface="Inter" pitchFamily="34" charset="-120"/>
+              </a:rPr>
+              <a:t>Tamper-evident logs, OpenTelemetry export, scoped agent identities, and savings reports of what was stopped.</a:t>
             </a:r>
             <a:endParaRPr lang="en-US" sz="1200" dirty="0"/>
           </a:p>
@@ -7237,12 +6989,12 @@
         </p:nvSpPr>
         <p:spPr>
           <a:xfrm>
-            <a:off x="7975600" y="4091880"/>
-            <a:ext cx="3403600" cy="1953320"/>
+            <a:off x="7975600" y="4202311"/>
+            <a:ext cx="3403600" cy="1842889"/>
           </a:xfrm>
           <a:prstGeom prst="roundRect">
             <a:avLst>
-              <a:gd name="adj" fmla="val 6502"/>
+              <a:gd name="adj" fmla="val 6891"/>
             </a:avLst>
           </a:prstGeom>
           <a:solidFill>
@@ -7266,7 +7018,7 @@
         </p:blipFill>
         <p:spPr>
           <a:xfrm>
-            <a:off x="8204200" y="4320480"/>
+            <a:off x="8204200" y="4430911"/>
             <a:ext cx="254000" cy="254000"/>
           </a:xfrm>
           <a:prstGeom prst="rect">
@@ -7282,8 +7034,8 @@
         </p:nvSpPr>
         <p:spPr>
           <a:xfrm>
-            <a:off x="8559800" y="4325541"/>
-            <a:ext cx="1301115" cy="269180"/>
+            <a:off x="8559800" y="4435971"/>
+            <a:ext cx="1364456" cy="269180"/>
           </a:xfrm>
           <a:prstGeom prst="rect">
             <a:avLst/>
@@ -7308,9 +7060,9 @@
                 <a:solidFill>
                   <a:srgbClr val="ECEFF3"/>
                 </a:solidFill>
-                <a:latin typeface="Arial" pitchFamily="34" charset="0"/>
-                <a:ea typeface="Arial" pitchFamily="34" charset="-122"/>
-                <a:cs typeface="Arial" pitchFamily="34" charset="-120"/>
+                <a:latin typeface="Inter" pitchFamily="34" charset="0"/>
+                <a:ea typeface="Inter" pitchFamily="34" charset="-122"/>
+                <a:cs typeface="Inter" pitchFamily="34" charset="-120"/>
               </a:rPr>
               <a:t>Data safety</a:t>
             </a:r>
@@ -7326,7 +7078,7 @@
         </p:nvSpPr>
         <p:spPr>
           <a:xfrm>
-            <a:off x="8204200" y="4663380"/>
+            <a:off x="8204200" y="4773811"/>
             <a:ext cx="3034792" cy="467320"/>
           </a:xfrm>
           <a:prstGeom prst="rect">
@@ -7352,9 +7104,9 @@
                 <a:solidFill>
                   <a:srgbClr val="B8C0CB"/>
                 </a:solidFill>
-                <a:latin typeface="Arial" pitchFamily="34" charset="0"/>
-                <a:ea typeface="Arial" pitchFamily="34" charset="-122"/>
-                <a:cs typeface="Arial" pitchFamily="34" charset="-120"/>
+                <a:latin typeface="Inter" pitchFamily="34" charset="0"/>
+                <a:ea typeface="Inter" pitchFamily="34" charset="-122"/>
+                <a:cs typeface="Inter" pitchFamily="34" charset="-120"/>
               </a:rPr>
               <a:t>PII redaction, prompt-injection filtering on tool output, and schema drift alerts.</a:t>
             </a:r>
@@ -7428,9 +7180,9 @@
                 <a:solidFill>
                   <a:srgbClr val="9A6A08"/>
                 </a:solidFill>
-                <a:latin typeface="Arial" pitchFamily="34" charset="0"/>
-                <a:ea typeface="Arial" pitchFamily="34" charset="-122"/>
-                <a:cs typeface="Arial" pitchFamily="34" charset="-120"/>
+                <a:latin typeface="Inter" pitchFamily="34" charset="0"/>
+                <a:ea typeface="Inter" pitchFamily="34" charset="-122"/>
+                <a:cs typeface="Inter" pitchFamily="34" charset="-120"/>
               </a:rPr>
               <a:t>HOW IT WORKS</a:t>
             </a:r>
@@ -7442,9 +7194,7 @@
         <p:nvSpPr>
           <p:cNvPr id="3" name="Text 1"/>
           <p:cNvSpPr/>
-          <p:nvPr>
-            <p:ph type="title"/>
-          </p:nvPr>
+          <p:nvPr/>
         </p:nvSpPr>
         <p:spPr>
           <a:xfrm>
@@ -7470,13 +7220,13 @@
               <a:buNone/>
             </a:pPr>
             <a:r>
-              <a:rPr lang="en-US" sz="3600" b="1" i="0" dirty="0">
+              <a:rPr lang="en-US" sz="3600" b="1" dirty="0">
                 <a:solidFill>
                   <a:srgbClr val="16191E"/>
                 </a:solidFill>
-                <a:latin typeface="Arial" pitchFamily="34" charset="0"/>
-                <a:ea typeface="Arial" pitchFamily="34" charset="-122"/>
-                <a:cs typeface="Arial" pitchFamily="34" charset="-120"/>
+                <a:latin typeface="Inter" pitchFamily="34" charset="0"/>
+                <a:ea typeface="Inter" pitchFamily="34" charset="-122"/>
+                <a:cs typeface="Inter" pitchFamily="34" charset="-120"/>
               </a:rPr>
               <a:t>The life of one agent call</a:t>
             </a:r>
@@ -7588,9 +7338,9 @@
                 <a:solidFill>
                   <a:srgbClr val="9A6A08"/>
                 </a:solidFill>
-                <a:latin typeface="Arial" pitchFamily="34" charset="0"/>
-                <a:ea typeface="Arial" pitchFamily="34" charset="-122"/>
-                <a:cs typeface="Arial" pitchFamily="34" charset="-120"/>
+                <a:latin typeface="Inter" pitchFamily="34" charset="0"/>
+                <a:ea typeface="Inter" pitchFamily="34" charset="-122"/>
+                <a:cs typeface="Inter" pitchFamily="34" charset="-120"/>
               </a:rPr>
               <a:t>01</a:t>
             </a:r>
@@ -7632,9 +7382,9 @@
                 <a:solidFill>
                   <a:srgbClr val="16191E"/>
                 </a:solidFill>
-                <a:latin typeface="Arial" pitchFamily="34" charset="0"/>
-                <a:ea typeface="Arial" pitchFamily="34" charset="-122"/>
-                <a:cs typeface="Arial" pitchFamily="34" charset="-120"/>
+                <a:latin typeface="Inter" pitchFamily="34" charset="0"/>
+                <a:ea typeface="Inter" pitchFamily="34" charset="-122"/>
+                <a:cs typeface="Inter" pitchFamily="34" charset="-120"/>
               </a:rPr>
               <a:t>Identify</a:t>
             </a:r>
@@ -7651,7 +7401,7 @@
         <p:spPr>
           <a:xfrm>
             <a:off x="1041400" y="2862362"/>
-            <a:ext cx="3034792" cy="467320"/>
+            <a:ext cx="3034792" cy="688280"/>
           </a:xfrm>
           <a:prstGeom prst="rect">
             <a:avLst/>
@@ -7676,9 +7426,9 @@
                 <a:solidFill>
                   <a:srgbClr val="4A5058"/>
                 </a:solidFill>
-                <a:latin typeface="Arial" pitchFamily="34" charset="0"/>
-                <a:ea typeface="Arial" pitchFamily="34" charset="-122"/>
-                <a:cs typeface="Arial" pitchFamily="34" charset="-120"/>
+                <a:latin typeface="Inter" pitchFamily="34" charset="0"/>
+                <a:ea typeface="Inter" pitchFamily="34" charset="-122"/>
+                <a:cs typeface="Inter" pitchFamily="34" charset="-120"/>
               </a:rPr>
               <a:t>An API key or a scoped agent token says which agent is acting, for which customer.</a:t>
             </a:r>
@@ -7790,9 +7540,9 @@
                 <a:solidFill>
                   <a:srgbClr val="9A6A08"/>
                 </a:solidFill>
-                <a:latin typeface="Arial" pitchFamily="34" charset="0"/>
-                <a:ea typeface="Arial" pitchFamily="34" charset="-122"/>
-                <a:cs typeface="Arial" pitchFamily="34" charset="-120"/>
+                <a:latin typeface="Inter" pitchFamily="34" charset="0"/>
+                <a:ea typeface="Inter" pitchFamily="34" charset="-122"/>
+                <a:cs typeface="Inter" pitchFamily="34" charset="-120"/>
               </a:rPr>
               <a:t>02</a:t>
             </a:r>
@@ -7834,9 +7584,9 @@
                 <a:solidFill>
                   <a:srgbClr val="16191E"/>
                 </a:solidFill>
-                <a:latin typeface="Arial" pitchFamily="34" charset="0"/>
-                <a:ea typeface="Arial" pitchFamily="34" charset="-122"/>
-                <a:cs typeface="Arial" pitchFamily="34" charset="-120"/>
+                <a:latin typeface="Inter" pitchFamily="34" charset="0"/>
+                <a:ea typeface="Inter" pitchFamily="34" charset="-122"/>
+                <a:cs typeface="Inter" pitchFamily="34" charset="-120"/>
               </a:rPr>
               <a:t>Validate</a:t>
             </a:r>
@@ -7878,9 +7628,9 @@
                 <a:solidFill>
                   <a:srgbClr val="4A5058"/>
                 </a:solidFill>
-                <a:latin typeface="Arial" pitchFamily="34" charset="0"/>
-                <a:ea typeface="Arial" pitchFamily="34" charset="-122"/>
-                <a:cs typeface="Arial" pitchFamily="34" charset="-120"/>
+                <a:latin typeface="Inter" pitchFamily="34" charset="0"/>
+                <a:ea typeface="Inter" pitchFamily="34" charset="-122"/>
+                <a:cs typeface="Inter" pitchFamily="34" charset="-120"/>
               </a:rPr>
               <a:t>Per-customer rules check the payload, such as amount limits or a refund above the balance.</a:t>
             </a:r>
@@ -7992,9 +7742,9 @@
                 <a:solidFill>
                   <a:srgbClr val="9A6A08"/>
                 </a:solidFill>
-                <a:latin typeface="Arial" pitchFamily="34" charset="0"/>
-                <a:ea typeface="Arial" pitchFamily="34" charset="-122"/>
-                <a:cs typeface="Arial" pitchFamily="34" charset="-120"/>
+                <a:latin typeface="Inter" pitchFamily="34" charset="0"/>
+                <a:ea typeface="Inter" pitchFamily="34" charset="-122"/>
+                <a:cs typeface="Inter" pitchFamily="34" charset="-120"/>
               </a:rPr>
               <a:t>03</a:t>
             </a:r>
@@ -8036,9 +7786,9 @@
                 <a:solidFill>
                   <a:srgbClr val="16191E"/>
                 </a:solidFill>
-                <a:latin typeface="Arial" pitchFamily="34" charset="0"/>
-                <a:ea typeface="Arial" pitchFamily="34" charset="-122"/>
-                <a:cs typeface="Arial" pitchFamily="34" charset="-120"/>
+                <a:latin typeface="Inter" pitchFamily="34" charset="0"/>
+                <a:ea typeface="Inter" pitchFamily="34" charset="-122"/>
+                <a:cs typeface="Inter" pitchFamily="34" charset="-120"/>
               </a:rPr>
               <a:t>Claim</a:t>
             </a:r>
@@ -8055,7 +7805,7 @@
         <p:spPr>
           <a:xfrm>
             <a:off x="8204200" y="2862362"/>
-            <a:ext cx="3034792" cy="467320"/>
+            <a:ext cx="3034792" cy="688280"/>
           </a:xfrm>
           <a:prstGeom prst="rect">
             <a:avLst/>
@@ -8080,9 +7830,9 @@
                 <a:solidFill>
                   <a:srgbClr val="4A5058"/>
                 </a:solidFill>
-                <a:latin typeface="Arial" pitchFamily="34" charset="0"/>
-                <a:ea typeface="Arial" pitchFamily="34" charset="-122"/>
-                <a:cs typeface="Arial" pitchFamily="34" charset="-120"/>
+                <a:latin typeface="Inter" pitchFamily="34" charset="0"/>
+                <a:ea typeface="Inter" pitchFamily="34" charset="-122"/>
+                <a:cs typeface="Inter" pitchFamily="34" charset="-120"/>
               </a:rPr>
               <a:t>An atomic dedup slot is taken. If it already exists, the stored result goes back instead.</a:t>
             </a:r>
@@ -8194,9 +7944,9 @@
                 <a:solidFill>
                   <a:srgbClr val="9A6A08"/>
                 </a:solidFill>
-                <a:latin typeface="Arial" pitchFamily="34" charset="0"/>
-                <a:ea typeface="Arial" pitchFamily="34" charset="-122"/>
-                <a:cs typeface="Arial" pitchFamily="34" charset="-120"/>
+                <a:latin typeface="Inter" pitchFamily="34" charset="0"/>
+                <a:ea typeface="Inter" pitchFamily="34" charset="-122"/>
+                <a:cs typeface="Inter" pitchFamily="34" charset="-120"/>
               </a:rPr>
               <a:t>04</a:t>
             </a:r>
@@ -8238,9 +7988,9 @@
                 <a:solidFill>
                   <a:srgbClr val="16191E"/>
                 </a:solidFill>
-                <a:latin typeface="Arial" pitchFamily="34" charset="0"/>
-                <a:ea typeface="Arial" pitchFamily="34" charset="-122"/>
-                <a:cs typeface="Arial" pitchFamily="34" charset="-120"/>
+                <a:latin typeface="Inter" pitchFamily="34" charset="0"/>
+                <a:ea typeface="Inter" pitchFamily="34" charset="-122"/>
+                <a:cs typeface="Inter" pitchFamily="34" charset="-120"/>
               </a:rPr>
               <a:t>Govern</a:t>
             </a:r>
@@ -8282,9 +8032,9 @@
                 <a:solidFill>
                   <a:srgbClr val="4A5058"/>
                 </a:solidFill>
-                <a:latin typeface="Arial" pitchFamily="34" charset="0"/>
-                <a:ea typeface="Arial" pitchFamily="34" charset="-122"/>
-                <a:cs typeface="Arial" pitchFamily="34" charset="-120"/>
+                <a:latin typeface="Inter" pitchFamily="34" charset="0"/>
+                <a:ea typeface="Inter" pitchFamily="34" charset="-122"/>
+                <a:cs typeface="Inter" pitchFamily="34" charset="-120"/>
               </a:rPr>
               <a:t>Spend caps and loop checks run; a call that needs approval waits for a human.</a:t>
             </a:r>
@@ -8396,9 +8146,9 @@
                 <a:solidFill>
                   <a:srgbClr val="9A6A08"/>
                 </a:solidFill>
-                <a:latin typeface="Arial" pitchFamily="34" charset="0"/>
-                <a:ea typeface="Arial" pitchFamily="34" charset="-122"/>
-                <a:cs typeface="Arial" pitchFamily="34" charset="-120"/>
+                <a:latin typeface="Inter" pitchFamily="34" charset="0"/>
+                <a:ea typeface="Inter" pitchFamily="34" charset="-122"/>
+                <a:cs typeface="Inter" pitchFamily="34" charset="-120"/>
               </a:rPr>
               <a:t>05</a:t>
             </a:r>
@@ -8440,9 +8190,9 @@
                 <a:solidFill>
                   <a:srgbClr val="16191E"/>
                 </a:solidFill>
-                <a:latin typeface="Arial" pitchFamily="34" charset="0"/>
-                <a:ea typeface="Arial" pitchFamily="34" charset="-122"/>
-                <a:cs typeface="Arial" pitchFamily="34" charset="-120"/>
+                <a:latin typeface="Inter" pitchFamily="34" charset="0"/>
+                <a:ea typeface="Inter" pitchFamily="34" charset="-122"/>
+                <a:cs typeface="Inter" pitchFamily="34" charset="-120"/>
               </a:rPr>
               <a:t>Execute</a:t>
             </a:r>
@@ -8484,9 +8234,9 @@
                 <a:solidFill>
                   <a:srgbClr val="4A5058"/>
                 </a:solidFill>
-                <a:latin typeface="Arial" pitchFamily="34" charset="0"/>
-                <a:ea typeface="Arial" pitchFamily="34" charset="-122"/>
-                <a:cs typeface="Arial" pitchFamily="34" charset="-120"/>
+                <a:latin typeface="Inter" pitchFamily="34" charset="0"/>
+                <a:ea typeface="Inter" pitchFamily="34" charset="-122"/>
+                <a:cs typeface="Inter" pitchFamily="34" charset="-120"/>
               </a:rPr>
               <a:t>Forwarded once with the customer's encrypted credentials, with retries and a circuit breaker.</a:t>
             </a:r>
@@ -8550,9 +8300,9 @@
                 <a:solidFill>
                   <a:srgbClr val="F2B544"/>
                 </a:solidFill>
-                <a:latin typeface="Arial" pitchFamily="34" charset="0"/>
-                <a:ea typeface="Arial" pitchFamily="34" charset="-122"/>
-                <a:cs typeface="Arial" pitchFamily="34" charset="-120"/>
+                <a:latin typeface="Inter" pitchFamily="34" charset="0"/>
+                <a:ea typeface="Inter" pitchFamily="34" charset="-122"/>
+                <a:cs typeface="Inter" pitchFamily="34" charset="-120"/>
               </a:rPr>
               <a:t>06</a:t>
             </a:r>
@@ -8594,9 +8344,9 @@
                 <a:solidFill>
                   <a:srgbClr val="ECEFF3"/>
                 </a:solidFill>
-                <a:latin typeface="Arial" pitchFamily="34" charset="0"/>
-                <a:ea typeface="Arial" pitchFamily="34" charset="-122"/>
-                <a:cs typeface="Arial" pitchFamily="34" charset="-120"/>
+                <a:latin typeface="Inter" pitchFamily="34" charset="0"/>
+                <a:ea typeface="Inter" pitchFamily="34" charset="-122"/>
+                <a:cs typeface="Inter" pitchFamily="34" charset="-120"/>
               </a:rPr>
               <a:t>Record</a:t>
             </a:r>
@@ -8638,9 +8388,9 @@
                 <a:solidFill>
                   <a:srgbClr val="B8C0CB"/>
                 </a:solidFill>
-                <a:latin typeface="Arial" pitchFamily="34" charset="0"/>
-                <a:ea typeface="Arial" pitchFamily="34" charset="-122"/>
-                <a:cs typeface="Arial" pitchFamily="34" charset="-120"/>
+                <a:latin typeface="Inter" pitchFamily="34" charset="0"/>
+                <a:ea typeface="Inter" pitchFamily="34" charset="-122"/>
+                <a:cs typeface="Inter" pitchFamily="34" charset="-120"/>
               </a:rPr>
               <a:t>Logged with the agent's identity. A failure lands in a queue for replay, never silently lost.</a:t>
             </a:r>
@@ -8714,9 +8464,9 @@
                 <a:solidFill>
                   <a:srgbClr val="9A6A08"/>
                 </a:solidFill>
-                <a:latin typeface="Arial" pitchFamily="34" charset="0"/>
-                <a:ea typeface="Arial" pitchFamily="34" charset="-122"/>
-                <a:cs typeface="Arial" pitchFamily="34" charset="-120"/>
+                <a:latin typeface="Inter" pitchFamily="34" charset="0"/>
+                <a:ea typeface="Inter" pitchFamily="34" charset="-122"/>
+                <a:cs typeface="Inter" pitchFamily="34" charset="-120"/>
               </a:rPr>
               <a:t>THE CORE MECHANISM</a:t>
             </a:r>
@@ -8728,9 +8478,7 @@
         <p:nvSpPr>
           <p:cNvPr id="3" name="Text 1"/>
           <p:cNvSpPr/>
-          <p:nvPr>
-            <p:ph type="title"/>
-          </p:nvPr>
+          <p:nvPr/>
         </p:nvSpPr>
         <p:spPr>
           <a:xfrm>
@@ -8756,13 +8504,13 @@
               <a:buNone/>
             </a:pPr>
             <a:r>
-              <a:rPr lang="en-US" sz="3600" b="1" i="0" dirty="0">
+              <a:rPr lang="en-US" sz="3600" b="1" dirty="0">
                 <a:solidFill>
                   <a:srgbClr val="16191E"/>
                 </a:solidFill>
-                <a:latin typeface="Arial" pitchFamily="34" charset="0"/>
-                <a:ea typeface="Arial" pitchFamily="34" charset="-122"/>
-                <a:cs typeface="Arial" pitchFamily="34" charset="-120"/>
+                <a:latin typeface="Inter" pitchFamily="34" charset="0"/>
+                <a:ea typeface="Inter" pitchFamily="34" charset="-122"/>
+                <a:cs typeface="Inter" pitchFamily="34" charset="-120"/>
               </a:rPr>
               <a:t>How exactly-once works</a:t>
             </a:r>
@@ -8778,7 +8526,7 @@
         </p:nvSpPr>
         <p:spPr>
           <a:xfrm>
-            <a:off x="812800" y="2966740"/>
+            <a:off x="812800" y="2960390"/>
             <a:ext cx="1574800" cy="238720"/>
           </a:xfrm>
           <a:prstGeom prst="rect">
@@ -8804,9 +8552,9 @@
                 <a:solidFill>
                   <a:srgbClr val="9A6A08"/>
                 </a:solidFill>
-                <a:latin typeface="Arial" pitchFamily="34" charset="0"/>
-                <a:ea typeface="Arial" pitchFamily="34" charset="-122"/>
-                <a:cs typeface="Arial" pitchFamily="34" charset="-120"/>
+                <a:latin typeface="Inter" pitchFamily="34" charset="0"/>
+                <a:ea typeface="Inter" pitchFamily="34" charset="-122"/>
+                <a:cs typeface="Inter" pitchFamily="34" charset="-120"/>
               </a:rPr>
               <a:t>First call</a:t>
             </a:r>
@@ -8822,12 +8570,12 @@
         </p:nvSpPr>
         <p:spPr>
           <a:xfrm>
-            <a:off x="2466975" y="2785765"/>
-            <a:ext cx="1765300" cy="575270"/>
+            <a:off x="2466975" y="2672755"/>
+            <a:ext cx="1765300" cy="788591"/>
           </a:xfrm>
           <a:prstGeom prst="roundRect">
             <a:avLst>
-              <a:gd name="adj" fmla="val 17109"/>
+              <a:gd name="adj" fmla="val 12481"/>
             </a:avLst>
           </a:prstGeom>
           <a:solidFill>
@@ -8857,9 +8605,9 @@
                 <a:solidFill>
                   <a:srgbClr val="16191E"/>
                 </a:solidFill>
-                <a:latin typeface="Arial" pitchFamily="34" charset="0"/>
-                <a:ea typeface="Arial" pitchFamily="34" charset="-122"/>
-                <a:cs typeface="Arial" pitchFamily="34" charset="-120"/>
+                <a:latin typeface="Inter" pitchFamily="34" charset="0"/>
+                <a:ea typeface="Inter" pitchFamily="34" charset="-122"/>
+                <a:cs typeface="Inter" pitchFamily="34" charset="-120"/>
               </a:rPr>
               <a:t>Agent sends the call</a:t>
             </a:r>
@@ -8882,7 +8630,7 @@
         </p:blipFill>
         <p:spPr>
           <a:xfrm>
-            <a:off x="4362450" y="2984500"/>
+            <a:off x="4362450" y="2978150"/>
             <a:ext cx="355600" cy="177800"/>
           </a:xfrm>
           <a:prstGeom prst="rect">
@@ -8898,7 +8646,7 @@
         </p:nvSpPr>
         <p:spPr>
           <a:xfrm>
-            <a:off x="4848225" y="2785765"/>
+            <a:off x="4848225" y="2779415"/>
             <a:ext cx="1765300" cy="575270"/>
           </a:xfrm>
           <a:prstGeom prst="roundRect">
@@ -8933,9 +8681,9 @@
                 <a:solidFill>
                   <a:srgbClr val="16191E"/>
                 </a:solidFill>
-                <a:latin typeface="Arial" pitchFamily="34" charset="0"/>
-                <a:ea typeface="Arial" pitchFamily="34" charset="-122"/>
-                <a:cs typeface="Arial" pitchFamily="34" charset="-120"/>
+                <a:latin typeface="Inter" pitchFamily="34" charset="0"/>
+                <a:ea typeface="Inter" pitchFamily="34" charset="-122"/>
+                <a:cs typeface="Inter" pitchFamily="34" charset="-120"/>
               </a:rPr>
               <a:t>Slot is free: claim it</a:t>
             </a:r>
@@ -8958,7 +8706,7 @@
         </p:blipFill>
         <p:spPr>
           <a:xfrm>
-            <a:off x="6743700" y="2984500"/>
+            <a:off x="6743700" y="2978150"/>
             <a:ext cx="355600" cy="177800"/>
           </a:xfrm>
           <a:prstGeom prst="rect">
@@ -8974,7 +8722,7 @@
         </p:nvSpPr>
         <p:spPr>
           <a:xfrm>
-            <a:off x="7229475" y="2785765"/>
+            <a:off x="7229475" y="2779415"/>
             <a:ext cx="1765300" cy="575270"/>
           </a:xfrm>
           <a:prstGeom prst="roundRect">
@@ -9009,9 +8757,9 @@
                 <a:solidFill>
                   <a:srgbClr val="16191E"/>
                 </a:solidFill>
-                <a:latin typeface="Arial" pitchFamily="34" charset="0"/>
-                <a:ea typeface="Arial" pitchFamily="34" charset="-122"/>
-                <a:cs typeface="Arial" pitchFamily="34" charset="-120"/>
+                <a:latin typeface="Inter" pitchFamily="34" charset="0"/>
+                <a:ea typeface="Inter" pitchFamily="34" charset="-122"/>
+                <a:cs typeface="Inter" pitchFamily="34" charset="-120"/>
               </a:rPr>
               <a:t>Real API runs once</a:t>
             </a:r>
@@ -9034,7 +8782,7 @@
         </p:blipFill>
         <p:spPr>
           <a:xfrm>
-            <a:off x="9124950" y="2984500"/>
+            <a:off x="9124950" y="2978150"/>
             <a:ext cx="355600" cy="177800"/>
           </a:xfrm>
           <a:prstGeom prst="rect">
@@ -9050,7 +8798,7 @@
         </p:nvSpPr>
         <p:spPr>
           <a:xfrm>
-            <a:off x="9610725" y="2785765"/>
+            <a:off x="9610725" y="2779415"/>
             <a:ext cx="1765300" cy="575270"/>
           </a:xfrm>
           <a:prstGeom prst="roundRect">
@@ -9085,9 +8833,9 @@
                 <a:solidFill>
                   <a:srgbClr val="16191E"/>
                 </a:solidFill>
-                <a:latin typeface="Arial" pitchFamily="34" charset="0"/>
-                <a:ea typeface="Arial" pitchFamily="34" charset="-122"/>
-                <a:cs typeface="Arial" pitchFamily="34" charset="-120"/>
+                <a:latin typeface="Inter" pitchFamily="34" charset="0"/>
+                <a:ea typeface="Inter" pitchFamily="34" charset="-122"/>
+                <a:cs typeface="Inter" pitchFamily="34" charset="-120"/>
               </a:rPr>
               <a:t>Result is stored</a:t>
             </a:r>
@@ -9103,7 +8851,7 @@
         </p:nvSpPr>
         <p:spPr>
           <a:xfrm>
-            <a:off x="812800" y="3851870"/>
+            <a:off x="812800" y="3958530"/>
             <a:ext cx="1574800" cy="238720"/>
           </a:xfrm>
           <a:prstGeom prst="rect">
@@ -9129,9 +8877,9 @@
                 <a:solidFill>
                   <a:srgbClr val="9A6A08"/>
                 </a:solidFill>
-                <a:latin typeface="Arial" pitchFamily="34" charset="0"/>
-                <a:ea typeface="Arial" pitchFamily="34" charset="-122"/>
-                <a:cs typeface="Arial" pitchFamily="34" charset="-120"/>
+                <a:latin typeface="Inter" pitchFamily="34" charset="0"/>
+                <a:ea typeface="Inter" pitchFamily="34" charset="-122"/>
+                <a:cs typeface="Inter" pitchFamily="34" charset="-120"/>
               </a:rPr>
               <a:t>Any retry</a:t>
             </a:r>
@@ -9148,11 +8896,11 @@
         <p:spPr>
           <a:xfrm>
             <a:off x="2466975" y="3670895"/>
-            <a:ext cx="2012950" cy="575270"/>
+            <a:ext cx="2012950" cy="788591"/>
           </a:xfrm>
           <a:prstGeom prst="roundRect">
             <a:avLst>
-              <a:gd name="adj" fmla="val 17109"/>
+              <a:gd name="adj" fmla="val 12481"/>
             </a:avLst>
           </a:prstGeom>
           <a:solidFill>
@@ -9182,9 +8930,9 @@
                 <a:solidFill>
                   <a:srgbClr val="16191E"/>
                 </a:solidFill>
-                <a:latin typeface="Arial" pitchFamily="34" charset="0"/>
-                <a:ea typeface="Arial" pitchFamily="34" charset="-122"/>
-                <a:cs typeface="Arial" pitchFamily="34" charset="-120"/>
+                <a:latin typeface="Inter" pitchFamily="34" charset="0"/>
+                <a:ea typeface="Inter" pitchFamily="34" charset="-122"/>
+                <a:cs typeface="Inter" pitchFamily="34" charset="-120"/>
               </a:rPr>
               <a:t>Same call arrives again</a:t>
             </a:r>
@@ -9207,7 +8955,7 @@
         </p:blipFill>
         <p:spPr>
           <a:xfrm>
-            <a:off x="4610100" y="3869630"/>
+            <a:off x="4610100" y="3976291"/>
             <a:ext cx="355600" cy="177800"/>
           </a:xfrm>
           <a:prstGeom prst="rect">
@@ -9223,7 +8971,7 @@
         </p:nvSpPr>
         <p:spPr>
           <a:xfrm>
-            <a:off x="5095875" y="3670895"/>
+            <a:off x="5095875" y="3777555"/>
             <a:ext cx="2012950" cy="575270"/>
           </a:xfrm>
           <a:prstGeom prst="roundRect">
@@ -9258,9 +9006,9 @@
                 <a:solidFill>
                   <a:srgbClr val="16191E"/>
                 </a:solidFill>
-                <a:latin typeface="Arial" pitchFamily="34" charset="0"/>
-                <a:ea typeface="Arial" pitchFamily="34" charset="-122"/>
-                <a:cs typeface="Arial" pitchFamily="34" charset="-120"/>
+                <a:latin typeface="Inter" pitchFamily="34" charset="0"/>
+                <a:ea typeface="Inter" pitchFamily="34" charset="-122"/>
+                <a:cs typeface="Inter" pitchFamily="34" charset="-120"/>
               </a:rPr>
               <a:t>Slot is taken</a:t>
             </a:r>
@@ -9283,7 +9031,7 @@
         </p:blipFill>
         <p:spPr>
           <a:xfrm>
-            <a:off x="7239000" y="3869630"/>
+            <a:off x="7239000" y="3976291"/>
             <a:ext cx="355600" cy="177800"/>
           </a:xfrm>
           <a:prstGeom prst="rect">
@@ -9299,7 +9047,7 @@
         </p:nvSpPr>
         <p:spPr>
           <a:xfrm>
-            <a:off x="7721600" y="3567410"/>
+            <a:off x="7721600" y="3674070"/>
             <a:ext cx="3657600" cy="782241"/>
           </a:xfrm>
           <a:prstGeom prst="roundRect">
@@ -9329,9 +9077,9 @@
                 <a:solidFill>
                   <a:srgbClr val="ECEFF3"/>
                 </a:solidFill>
-                <a:latin typeface="Arial" pitchFamily="34" charset="0"/>
-                <a:ea typeface="Arial" pitchFamily="34" charset="-122"/>
-                <a:cs typeface="Arial" pitchFamily="34" charset="-120"/>
+                <a:latin typeface="Inter" pitchFamily="34" charset="0"/>
+                <a:ea typeface="Inter" pitchFamily="34" charset="-122"/>
+                <a:cs typeface="Inter" pitchFamily="34" charset="-120"/>
               </a:rPr>
               <a:t>Stored result returned. The real API is never called.</a:t>
             </a:r>
@@ -9373,9 +9121,9 @@
                 <a:solidFill>
                   <a:srgbClr val="4A5058"/>
                 </a:solidFill>
-                <a:latin typeface="Arial" pitchFamily="34" charset="0"/>
-                <a:ea typeface="Arial" pitchFamily="34" charset="-122"/>
-                <a:cs typeface="Arial" pitchFamily="34" charset="-120"/>
+                <a:latin typeface="Inter" pitchFamily="34" charset="0"/>
+                <a:ea typeface="Inter" pitchFamily="34" charset="-122"/>
+                <a:cs typeface="Inter" pitchFamily="34" charset="-120"/>
               </a:rPr>
               <a:t>The slot is claimed atomically in shared storage, so it holds across retries, crashed workers and many machines at once, and it is proven under real concurrent load.</a:t>
             </a:r>
@@ -9449,11 +9197,11 @@
                 <a:solidFill>
                   <a:srgbClr val="9A6A08"/>
                 </a:solidFill>
-                <a:latin typeface="Arial" pitchFamily="34" charset="0"/>
-                <a:ea typeface="Arial" pitchFamily="34" charset="-122"/>
-                <a:cs typeface="Arial" pitchFamily="34" charset="-120"/>
-              </a:rPr>
-              <a:t>WHEN SOMETHING GOES WRONG</a:t>
+                <a:latin typeface="Inter" pitchFamily="34" charset="0"/>
+                <a:ea typeface="Inter" pitchFamily="34" charset="-122"/>
+                <a:cs typeface="Inter" pitchFamily="34" charset="-120"/>
+              </a:rPr>
+              <a:t>BEFORE AND AFTER IT GOES LIVE</a:t>
             </a:r>
             <a:endParaRPr lang="en-US" sz="1200" dirty="0"/>
           </a:p>
@@ -9463,9 +9211,7 @@
         <p:nvSpPr>
           <p:cNvPr id="3" name="Text 1"/>
           <p:cNvSpPr/>
-          <p:nvPr>
-            <p:ph type="title"/>
-          </p:nvPr>
+          <p:nvPr/>
         </p:nvSpPr>
         <p:spPr>
           <a:xfrm>
@@ -9491,15 +9237,15 @@
               <a:buNone/>
             </a:pPr>
             <a:r>
-              <a:rPr lang="en-US" sz="3600" b="1" i="0" dirty="0">
+              <a:rPr lang="en-US" sz="3600" b="1" dirty="0">
                 <a:solidFill>
                   <a:srgbClr val="16191E"/>
                 </a:solidFill>
-                <a:latin typeface="Arial" pitchFamily="34" charset="0"/>
-                <a:ea typeface="Arial" pitchFamily="34" charset="-122"/>
-                <a:cs typeface="Arial" pitchFamily="34" charset="-120"/>
-              </a:rPr>
-              <a:t>Undo it, or test it before it ships</a:t>
+                <a:latin typeface="Inter" pitchFamily="34" charset="0"/>
+                <a:ea typeface="Inter" pitchFamily="34" charset="-122"/>
+                <a:cs typeface="Inter" pitchFamily="34" charset="-120"/>
+              </a:rPr>
+              <a:t>Try it safely, undo what went wrong</a:t>
             </a:r>
             <a:endParaRPr lang="en-US" sz="3600" dirty="0"/>
           </a:p>
@@ -9513,12 +9259,210 @@
         </p:nvSpPr>
         <p:spPr>
           <a:xfrm>
-            <a:off x="815975" y="1963936"/>
-            <a:ext cx="5181600" cy="4078089"/>
+            <a:off x="812800" y="1960761"/>
+            <a:ext cx="3395067" cy="4084439"/>
           </a:xfrm>
           <a:prstGeom prst="roundRect">
             <a:avLst>
-              <a:gd name="adj" fmla="val 3036"/>
+              <a:gd name="adj" fmla="val 3741"/>
+            </a:avLst>
+          </a:prstGeom>
+          <a:solidFill>
+            <a:srgbClr val="16191E"/>
+          </a:solidFill>
+          <a:ln/>
+        </p:spPr>
+      </p:sp>
+      <p:sp>
+        <p:nvSpPr>
+          <p:cNvPr id="5" name="Text 3"/>
+          <p:cNvSpPr/>
+          <p:nvPr/>
+        </p:nvSpPr>
+        <p:spPr>
+          <a:xfrm>
+            <a:off x="1041400" y="2189361"/>
+            <a:ext cx="3026003" cy="238720"/>
+          </a:xfrm>
+          <a:prstGeom prst="rect">
+            <a:avLst/>
+          </a:prstGeom>
+          <a:noFill/>
+          <a:ln/>
+        </p:spPr>
+        <p:txBody>
+          <a:bodyPr wrap="square" lIns="0" tIns="0" rIns="0" bIns="0" rtlCol="0" anchor="t">
+            <a:normAutofit/>
+          </a:bodyPr>
+          <a:lstStyle/>
+          <a:p>
+            <a:pPr algn="l" indent="0" marL="0">
+              <a:lnSpc>
+                <a:spcPts val="1680"/>
+              </a:lnSpc>
+              <a:buNone/>
+            </a:pPr>
+            <a:r>
+              <a:rPr lang="en-US" sz="1200" b="1" dirty="0">
+                <a:solidFill>
+                  <a:srgbClr val="F2B544"/>
+                </a:solidFill>
+                <a:latin typeface="Inter" pitchFamily="34" charset="0"/>
+                <a:ea typeface="Inter" pitchFamily="34" charset="-122"/>
+                <a:cs typeface="Inter" pitchFamily="34" charset="-120"/>
+              </a:rPr>
+              <a:t>Shadow mode</a:t>
+            </a:r>
+            <a:endParaRPr lang="en-US" sz="1200" dirty="0"/>
+          </a:p>
+        </p:txBody>
+      </p:sp>
+      <p:sp>
+        <p:nvSpPr>
+          <p:cNvPr id="6" name="Text 4"/>
+          <p:cNvSpPr/>
+          <p:nvPr/>
+        </p:nvSpPr>
+        <p:spPr>
+          <a:xfrm>
+            <a:off x="1041400" y="2504281"/>
+            <a:ext cx="3026003" cy="269180"/>
+          </a:xfrm>
+          <a:prstGeom prst="rect">
+            <a:avLst/>
+          </a:prstGeom>
+          <a:noFill/>
+          <a:ln/>
+        </p:spPr>
+        <p:txBody>
+          <a:bodyPr wrap="square" lIns="0" tIns="0" rIns="0" bIns="0" rtlCol="0" anchor="t">
+            <a:normAutofit/>
+          </a:bodyPr>
+          <a:lstStyle/>
+          <a:p>
+            <a:pPr algn="l" indent="0" marL="0">
+              <a:lnSpc>
+                <a:spcPts val="1920"/>
+              </a:lnSpc>
+              <a:buNone/>
+            </a:pPr>
+            <a:r>
+              <a:rPr lang="en-US" sz="1600" b="1" dirty="0">
+                <a:solidFill>
+                  <a:srgbClr val="ECEFF3"/>
+                </a:solidFill>
+                <a:latin typeface="Inter" pitchFamily="34" charset="0"/>
+                <a:ea typeface="Inter" pitchFamily="34" charset="-122"/>
+                <a:cs typeface="Inter" pitchFamily="34" charset="-120"/>
+              </a:rPr>
+              <a:t>Real traffic, nothing sent</a:t>
+            </a:r>
+            <a:endParaRPr lang="en-US" sz="1600" dirty="0"/>
+          </a:p>
+        </p:txBody>
+      </p:sp>
+      <p:sp>
+        <p:nvSpPr>
+          <p:cNvPr id="7" name="Text 5"/>
+          <p:cNvSpPr/>
+          <p:nvPr/>
+        </p:nvSpPr>
+        <p:spPr>
+          <a:xfrm>
+            <a:off x="1041400" y="2849662"/>
+            <a:ext cx="3026003" cy="909241"/>
+          </a:xfrm>
+          <a:prstGeom prst="rect">
+            <a:avLst/>
+          </a:prstGeom>
+          <a:noFill/>
+          <a:ln/>
+        </p:spPr>
+        <p:txBody>
+          <a:bodyPr wrap="square" lIns="0" tIns="0" rIns="0" bIns="0" rtlCol="0" anchor="t">
+            <a:normAutofit/>
+          </a:bodyPr>
+          <a:lstStyle/>
+          <a:p>
+            <a:pPr algn="l" indent="0" marL="0">
+              <a:lnSpc>
+                <a:spcPts val="1740"/>
+              </a:lnSpc>
+              <a:buNone/>
+            </a:pPr>
+            <a:r>
+              <a:rPr lang="en-US" sz="1200" dirty="0">
+                <a:solidFill>
+                  <a:srgbClr val="B8C0CB"/>
+                </a:solidFill>
+                <a:latin typeface="Inter" pitchFamily="34" charset="0"/>
+                <a:ea typeface="Inter" pitchFamily="34" charset="-122"/>
+                <a:cs typeface="Inter" pitchFamily="34" charset="-120"/>
+              </a:rPr>
+              <a:t>A new agent runs on real requests. Every write is checked against your rules and recorded with what would have happened, but never sent.</a:t>
+            </a:r>
+            <a:endParaRPr lang="en-US" sz="1200" dirty="0"/>
+          </a:p>
+        </p:txBody>
+      </p:sp>
+      <p:sp>
+        <p:nvSpPr>
+          <p:cNvPr id="8" name="Text 6"/>
+          <p:cNvSpPr/>
+          <p:nvPr/>
+        </p:nvSpPr>
+        <p:spPr>
+          <a:xfrm>
+            <a:off x="1041400" y="3835102"/>
+            <a:ext cx="3026003" cy="467320"/>
+          </a:xfrm>
+          <a:prstGeom prst="rect">
+            <a:avLst/>
+          </a:prstGeom>
+          <a:noFill/>
+          <a:ln/>
+        </p:spPr>
+        <p:txBody>
+          <a:bodyPr wrap="square" lIns="0" tIns="0" rIns="0" bIns="0" rtlCol="0" anchor="t">
+            <a:normAutofit/>
+          </a:bodyPr>
+          <a:lstStyle/>
+          <a:p>
+            <a:pPr algn="l" indent="0" marL="0">
+              <a:lnSpc>
+                <a:spcPts val="1740"/>
+              </a:lnSpc>
+              <a:buNone/>
+            </a:pPr>
+            <a:r>
+              <a:rPr lang="en-US" sz="1200" dirty="0">
+                <a:solidFill>
+                  <a:srgbClr val="B8C0CB"/>
+                </a:solidFill>
+                <a:latin typeface="Inter" pitchFamily="34" charset="0"/>
+                <a:ea typeface="Inter" pitchFamily="34" charset="-122"/>
+                <a:cs typeface="Inter" pitchFamily="34" charset="-120"/>
+              </a:rPr>
+              <a:t>Go live with one click when the record looks right.</a:t>
+            </a:r>
+            <a:endParaRPr lang="en-US" sz="1200" dirty="0"/>
+          </a:p>
+        </p:txBody>
+      </p:sp>
+      <p:sp>
+        <p:nvSpPr>
+          <p:cNvPr id="9" name="Shape 7"/>
+          <p:cNvSpPr/>
+          <p:nvPr/>
+        </p:nvSpPr>
+        <p:spPr>
+          <a:xfrm>
+            <a:off x="4388842" y="1963936"/>
+            <a:ext cx="3401516" cy="4078089"/>
+          </a:xfrm>
+          <a:prstGeom prst="roundRect">
+            <a:avLst>
+              <a:gd name="adj" fmla="val 3640"/>
             </a:avLst>
           </a:prstGeom>
           <a:solidFill>
@@ -9534,14 +9478,14 @@
       </p:sp>
       <p:sp>
         <p:nvSpPr>
-          <p:cNvPr id="5" name="Text 3"/>
-          <p:cNvSpPr/>
-          <p:nvPr/>
-        </p:nvSpPr>
-        <p:spPr>
-          <a:xfrm>
-            <a:off x="1073150" y="2221111"/>
-            <a:ext cx="4807268" cy="238720"/>
+          <p:cNvPr id="10" name="Text 8"/>
+          <p:cNvSpPr/>
+          <p:nvPr/>
+        </p:nvSpPr>
+        <p:spPr>
+          <a:xfrm>
+            <a:off x="4620617" y="2195711"/>
+            <a:ext cx="3026105" cy="238720"/>
           </a:xfrm>
           <a:prstGeom prst="rect">
             <a:avLst/>
@@ -9566,11 +9510,11 @@
                 <a:solidFill>
                   <a:srgbClr val="9A6A08"/>
                 </a:solidFill>
-                <a:latin typeface="Arial" pitchFamily="34" charset="0"/>
-                <a:ea typeface="Arial" pitchFamily="34" charset="-122"/>
-                <a:cs typeface="Arial" pitchFamily="34" charset="-120"/>
-              </a:rPr>
-              <a:t>Undo log</a:t>
+                <a:latin typeface="Inter" pitchFamily="34" charset="0"/>
+                <a:ea typeface="Inter" pitchFamily="34" charset="-122"/>
+                <a:cs typeface="Inter" pitchFamily="34" charset="-120"/>
+              </a:rPr>
+              <a:t>Record and replay</a:t>
             </a:r>
             <a:endParaRPr lang="en-US" sz="1200" dirty="0"/>
           </a:p>
@@ -9578,14 +9522,14 @@
       </p:sp>
       <p:sp>
         <p:nvSpPr>
-          <p:cNvPr id="6" name="Text 4"/>
-          <p:cNvSpPr/>
-          <p:nvPr/>
-        </p:nvSpPr>
-        <p:spPr>
-          <a:xfrm>
-            <a:off x="1073150" y="2536031"/>
-            <a:ext cx="4807268" cy="269180"/>
+          <p:cNvPr id="11" name="Text 9"/>
+          <p:cNvSpPr/>
+          <p:nvPr/>
+        </p:nvSpPr>
+        <p:spPr>
+          <a:xfrm>
+            <a:off x="4620617" y="2510631"/>
+            <a:ext cx="3026105" cy="269180"/>
           </a:xfrm>
           <a:prstGeom prst="rect">
             <a:avLst/>
@@ -9610,11 +9554,11 @@
                 <a:solidFill>
                   <a:srgbClr val="16191E"/>
                 </a:solidFill>
-                <a:latin typeface="Arial" pitchFamily="34" charset="0"/>
-                <a:ea typeface="Arial" pitchFamily="34" charset="-122"/>
-                <a:cs typeface="Arial" pitchFamily="34" charset="-120"/>
-              </a:rPr>
-              <a:t>Reverse an action, once</a:t>
+                <a:latin typeface="Inter" pitchFamily="34" charset="0"/>
+                <a:ea typeface="Inter" pitchFamily="34" charset="-122"/>
+                <a:cs typeface="Inter" pitchFamily="34" charset="-120"/>
+              </a:rPr>
+              <a:t>Test against real answers</a:t>
             </a:r>
             <a:endParaRPr lang="en-US" sz="1600" dirty="0"/>
           </a:p>
@@ -9622,14 +9566,14 @@
       </p:sp>
       <p:sp>
         <p:nvSpPr>
-          <p:cNvPr id="7" name="Text 5"/>
-          <p:cNvSpPr/>
-          <p:nvPr/>
-        </p:nvSpPr>
-        <p:spPr>
-          <a:xfrm>
-            <a:off x="1073150" y="2881412"/>
-            <a:ext cx="4807268" cy="467320"/>
+          <p:cNvPr id="12" name="Text 10"/>
+          <p:cNvSpPr/>
+          <p:nvPr/>
+        </p:nvSpPr>
+        <p:spPr>
+          <a:xfrm>
+            <a:off x="4620617" y="2856012"/>
+            <a:ext cx="3026105" cy="909241"/>
           </a:xfrm>
           <a:prstGeom prst="rect">
             <a:avLst/>
@@ -9654,11 +9598,11 @@
                 <a:solidFill>
                   <a:srgbClr val="4A5058"/>
                 </a:solidFill>
-                <a:latin typeface="Arial" pitchFamily="34" charset="0"/>
-                <a:ea typeface="Arial" pitchFamily="34" charset="-122"/>
-                <a:cs typeface="Arial" pitchFamily="34" charset="-120"/>
-              </a:rPr>
-              <a:t>A Stripe charge is refunded, a Slack message deleted, a custom action reversed by the action you name.</a:t>
+                <a:latin typeface="Inter" pitchFamily="34" charset="0"/>
+                <a:ea typeface="Inter" pitchFamily="34" charset="-122"/>
+                <a:cs typeface="Inter" pitchFamily="34" charset="-120"/>
+              </a:rPr>
+              <a:t>Record a run once against the real providers, then replay it in CI or after a prompt change. Nothing reaches the provider.</a:t>
             </a:r>
             <a:endParaRPr lang="en-US" sz="1200" dirty="0"/>
           </a:p>
@@ -9666,14 +9610,14 @@
       </p:sp>
       <p:sp>
         <p:nvSpPr>
-          <p:cNvPr id="8" name="Text 6"/>
-          <p:cNvSpPr/>
-          <p:nvPr/>
-        </p:nvSpPr>
-        <p:spPr>
-          <a:xfrm>
-            <a:off x="1073150" y="3424932"/>
-            <a:ext cx="4807268" cy="467320"/>
+          <p:cNvPr id="13" name="Text 11"/>
+          <p:cNvSpPr/>
+          <p:nvPr/>
+        </p:nvSpPr>
+        <p:spPr>
+          <a:xfrm>
+            <a:off x="4620617" y="3841452"/>
+            <a:ext cx="3026105" cy="246360"/>
           </a:xfrm>
           <a:prstGeom prst="rect">
             <a:avLst/>
@@ -9698,11 +9642,11 @@
                 <a:solidFill>
                   <a:srgbClr val="4A5058"/>
                 </a:solidFill>
-                <a:latin typeface="Arial" pitchFamily="34" charset="0"/>
-                <a:ea typeface="Arial" pitchFamily="34" charset="-122"/>
-                <a:cs typeface="Arial" pitchFamily="34" charset="-120"/>
-              </a:rPr>
-              <a:t>Kept for 30 days. Two clicks at the same moment still reverse it only once.</a:t>
+                <a:latin typeface="Inter" pitchFamily="34" charset="0"/>
+                <a:ea typeface="Inter" pitchFamily="34" charset="-122"/>
+                <a:cs typeface="Inter" pitchFamily="34" charset="-120"/>
+              </a:rPr>
+              <a:t>A changed payload fails the test.</a:t>
             </a:r>
             <a:endParaRPr lang="en-US" sz="1200" dirty="0"/>
           </a:p>
@@ -9710,80 +9654,41 @@
       </p:sp>
       <p:sp>
         <p:nvSpPr>
-          <p:cNvPr id="9" name="Text 7"/>
-          <p:cNvSpPr/>
-          <p:nvPr/>
-        </p:nvSpPr>
-        <p:spPr>
-          <a:xfrm>
-            <a:off x="1073150" y="3968452"/>
-            <a:ext cx="4807268" cy="246360"/>
-          </a:xfrm>
-          <a:prstGeom prst="rect">
-            <a:avLst/>
-          </a:prstGeom>
-          <a:noFill/>
-          <a:ln/>
-        </p:spPr>
-        <p:txBody>
-          <a:bodyPr wrap="square" lIns="0" tIns="0" rIns="0" bIns="0" rtlCol="0" anchor="t">
-            <a:normAutofit/>
-          </a:bodyPr>
-          <a:lstStyle/>
-          <a:p>
-            <a:pPr algn="l" indent="0" marL="0">
-              <a:lnSpc>
-                <a:spcPts val="1740"/>
-              </a:lnSpc>
-              <a:buNone/>
-            </a:pPr>
-            <a:r>
-              <a:rPr lang="en-US" sz="1200" dirty="0">
-                <a:solidFill>
-                  <a:srgbClr val="4A5058"/>
-                </a:solidFill>
-                <a:latin typeface="Arial" pitchFamily="34" charset="0"/>
-                <a:ea typeface="Arial" pitchFamily="34" charset="-122"/>
-                <a:cs typeface="Arial" pitchFamily="34" charset="-120"/>
-              </a:rPr>
-              <a:t>In the dashboard: Monitor, Undo actions.</a:t>
-            </a:r>
-            <a:endParaRPr lang="en-US" sz="1200" dirty="0"/>
-          </a:p>
-        </p:txBody>
-      </p:sp>
-      <p:sp>
-        <p:nvSpPr>
-          <p:cNvPr id="10" name="Shape 8"/>
-          <p:cNvSpPr/>
-          <p:nvPr/>
-        </p:nvSpPr>
-        <p:spPr>
-          <a:xfrm>
-            <a:off x="6203950" y="1960761"/>
-            <a:ext cx="5175250" cy="4084439"/>
+          <p:cNvPr id="14" name="Shape 12"/>
+          <p:cNvSpPr/>
+          <p:nvPr/>
+        </p:nvSpPr>
+        <p:spPr>
+          <a:xfrm>
+            <a:off x="7974509" y="1963936"/>
+            <a:ext cx="3401516" cy="4078089"/>
           </a:xfrm>
           <a:prstGeom prst="roundRect">
             <a:avLst>
-              <a:gd name="adj" fmla="val 3109"/>
+              <a:gd name="adj" fmla="val 3640"/>
             </a:avLst>
           </a:prstGeom>
           <a:solidFill>
-            <a:srgbClr val="16191E"/>
+            <a:srgbClr val="F7F6F2"/>
           </a:solidFill>
-          <a:ln/>
-        </p:spPr>
-      </p:sp>
-      <p:sp>
-        <p:nvSpPr>
-          <p:cNvPr id="11" name="Text 9"/>
-          <p:cNvSpPr/>
-          <p:nvPr/>
-        </p:nvSpPr>
-        <p:spPr>
-          <a:xfrm>
-            <a:off x="6457950" y="2214761"/>
-            <a:ext cx="4807268" cy="238720"/>
+          <a:ln w="6350">
+            <a:solidFill>
+              <a:srgbClr val="E4E2DC"/>
+            </a:solidFill>
+            <a:prstDash val="solid"/>
+          </a:ln>
+        </p:spPr>
+      </p:sp>
+      <p:sp>
+        <p:nvSpPr>
+          <p:cNvPr id="15" name="Text 13"/>
+          <p:cNvSpPr/>
+          <p:nvPr/>
+        </p:nvSpPr>
+        <p:spPr>
+          <a:xfrm>
+            <a:off x="8206284" y="2195711"/>
+            <a:ext cx="3026105" cy="238720"/>
           </a:xfrm>
           <a:prstGeom prst="rect">
             <a:avLst/>
@@ -9806,13 +9711,13 @@
             <a:r>
               <a:rPr lang="en-US" sz="1200" b="1" dirty="0">
                 <a:solidFill>
-                  <a:srgbClr val="F2B544"/>
-                </a:solidFill>
-                <a:latin typeface="Arial" pitchFamily="34" charset="0"/>
-                <a:ea typeface="Arial" pitchFamily="34" charset="-122"/>
-                <a:cs typeface="Arial" pitchFamily="34" charset="-120"/>
-              </a:rPr>
-              <a:t>Record and replay</a:t>
+                  <a:srgbClr val="9A6A08"/>
+                </a:solidFill>
+                <a:latin typeface="Inter" pitchFamily="34" charset="0"/>
+                <a:ea typeface="Inter" pitchFamily="34" charset="-122"/>
+                <a:cs typeface="Inter" pitchFamily="34" charset="-120"/>
+              </a:rPr>
+              <a:t>Undo log</a:t>
             </a:r>
             <a:endParaRPr lang="en-US" sz="1200" dirty="0"/>
           </a:p>
@@ -9820,14 +9725,14 @@
       </p:sp>
       <p:sp>
         <p:nvSpPr>
-          <p:cNvPr id="12" name="Text 10"/>
-          <p:cNvSpPr/>
-          <p:nvPr/>
-        </p:nvSpPr>
-        <p:spPr>
-          <a:xfrm>
-            <a:off x="6457950" y="2529681"/>
-            <a:ext cx="4807268" cy="269180"/>
+          <p:cNvPr id="16" name="Text 14"/>
+          <p:cNvSpPr/>
+          <p:nvPr/>
+        </p:nvSpPr>
+        <p:spPr>
+          <a:xfrm>
+            <a:off x="8206284" y="2510631"/>
+            <a:ext cx="3026105" cy="269180"/>
           </a:xfrm>
           <a:prstGeom prst="rect">
             <a:avLst/>
@@ -9850,13 +9755,13 @@
             <a:r>
               <a:rPr lang="en-US" sz="1600" b="1" dirty="0">
                 <a:solidFill>
-                  <a:srgbClr val="ECEFF3"/>
-                </a:solidFill>
-                <a:latin typeface="Arial" pitchFamily="34" charset="0"/>
-                <a:ea typeface="Arial" pitchFamily="34" charset="-122"/>
-                <a:cs typeface="Arial" pitchFamily="34" charset="-120"/>
-              </a:rPr>
-              <a:t>Test against real answers</a:t>
+                  <a:srgbClr val="16191E"/>
+                </a:solidFill>
+                <a:latin typeface="Inter" pitchFamily="34" charset="0"/>
+                <a:ea typeface="Inter" pitchFamily="34" charset="-122"/>
+                <a:cs typeface="Inter" pitchFamily="34" charset="-120"/>
+              </a:rPr>
+              <a:t>Reverse an action, once</a:t>
             </a:r>
             <a:endParaRPr lang="en-US" sz="1600" dirty="0"/>
           </a:p>
@@ -9864,14 +9769,14 @@
       </p:sp>
       <p:sp>
         <p:nvSpPr>
-          <p:cNvPr id="13" name="Text 11"/>
-          <p:cNvSpPr/>
-          <p:nvPr/>
-        </p:nvSpPr>
-        <p:spPr>
-          <a:xfrm>
-            <a:off x="6457950" y="2875062"/>
-            <a:ext cx="4807268" cy="467320"/>
+          <p:cNvPr id="17" name="Text 15"/>
+          <p:cNvSpPr/>
+          <p:nvPr/>
+        </p:nvSpPr>
+        <p:spPr>
+          <a:xfrm>
+            <a:off x="8206284" y="2856012"/>
+            <a:ext cx="3026105" cy="688280"/>
           </a:xfrm>
           <a:prstGeom prst="rect">
             <a:avLst/>
@@ -9894,13 +9799,13 @@
             <a:r>
               <a:rPr lang="en-US" sz="1200" dirty="0">
                 <a:solidFill>
-                  <a:srgbClr val="B8C0CB"/>
-                </a:solidFill>
-                <a:latin typeface="Arial" pitchFamily="34" charset="0"/>
-                <a:ea typeface="Arial" pitchFamily="34" charset="-122"/>
-                <a:cs typeface="Arial" pitchFamily="34" charset="-120"/>
-              </a:rPr>
-              <a:t>Record a run once against the real providers, then replay it in CI or after a prompt change.</a:t>
+                  <a:srgbClr val="4A5058"/>
+                </a:solidFill>
+                <a:latin typeface="Inter" pitchFamily="34" charset="0"/>
+                <a:ea typeface="Inter" pitchFamily="34" charset="-122"/>
+                <a:cs typeface="Inter" pitchFamily="34" charset="-120"/>
+              </a:rPr>
+              <a:t>A Stripe charge refunded, a Slack message deleted, or your own reverse action.</a:t>
             </a:r>
             <a:endParaRPr lang="en-US" sz="1200" dirty="0"/>
           </a:p>
@@ -9908,14 +9813,14 @@
       </p:sp>
       <p:sp>
         <p:nvSpPr>
-          <p:cNvPr id="14" name="Text 12"/>
-          <p:cNvSpPr/>
-          <p:nvPr/>
-        </p:nvSpPr>
-        <p:spPr>
-          <a:xfrm>
-            <a:off x="6457950" y="3418582"/>
-            <a:ext cx="4807268" cy="688280"/>
+          <p:cNvPr id="18" name="Text 16"/>
+          <p:cNvSpPr/>
+          <p:nvPr/>
+        </p:nvSpPr>
+        <p:spPr>
+          <a:xfrm>
+            <a:off x="8206284" y="3620492"/>
+            <a:ext cx="3026105" cy="467320"/>
           </a:xfrm>
           <a:prstGeom prst="rect">
             <a:avLst/>
@@ -9938,57 +9843,13 @@
             <a:r>
               <a:rPr lang="en-US" sz="1200" dirty="0">
                 <a:solidFill>
-                  <a:srgbClr val="B8C0CB"/>
-                </a:solidFill>
-                <a:latin typeface="Arial" pitchFamily="34" charset="0"/>
-                <a:ea typeface="Arial" pitchFamily="34" charset="-122"/>
-                <a:cs typeface="Arial" pitchFamily="34" charset="-120"/>
-              </a:rPr>
-              <a:t>Every call is answered from the recording; nothing reaches the provider. A changed payload or a call the recording lacks fails the test.</a:t>
-            </a:r>
-            <a:endParaRPr lang="en-US" sz="1200" dirty="0"/>
-          </a:p>
-        </p:txBody>
-      </p:sp>
-      <p:sp>
-        <p:nvSpPr>
-          <p:cNvPr id="15" name="Text 13"/>
-          <p:cNvSpPr/>
-          <p:nvPr/>
-        </p:nvSpPr>
-        <p:spPr>
-          <a:xfrm>
-            <a:off x="6457950" y="4183063"/>
-            <a:ext cx="4807268" cy="246360"/>
-          </a:xfrm>
-          <a:prstGeom prst="rect">
-            <a:avLst/>
-          </a:prstGeom>
-          <a:noFill/>
-          <a:ln/>
-        </p:spPr>
-        <p:txBody>
-          <a:bodyPr wrap="square" lIns="0" tIns="0" rIns="0" bIns="0" rtlCol="0" anchor="t">
-            <a:normAutofit/>
-          </a:bodyPr>
-          <a:lstStyle/>
-          <a:p>
-            <a:pPr algn="l" indent="0" marL="0">
-              <a:lnSpc>
-                <a:spcPts val="1740"/>
-              </a:lnSpc>
-              <a:buNone/>
-            </a:pPr>
-            <a:r>
-              <a:rPr lang="en-US" sz="1200" dirty="0">
-                <a:solidFill>
-                  <a:srgbClr val="B8C0CB"/>
-                </a:solidFill>
-                <a:latin typeface="Arial" pitchFamily="34" charset="0"/>
-                <a:ea typeface="Arial" pitchFamily="34" charset="-122"/>
-                <a:cs typeface="Arial" pitchFamily="34" charset="-120"/>
-              </a:rPr>
-              <a:t>Webhook, Python and TypeScript SDK, and MCP.</a:t>
+                  <a:srgbClr val="4A5058"/>
+                </a:solidFill>
+                <a:latin typeface="Inter" pitchFamily="34" charset="0"/>
+                <a:ea typeface="Inter" pitchFamily="34" charset="-122"/>
+                <a:cs typeface="Inter" pitchFamily="34" charset="-120"/>
+              </a:rPr>
+              <a:t>Kept for 30 days; two clicks at once still reverse it only once.</a:t>
             </a:r>
             <a:endParaRPr lang="en-US" sz="1200" dirty="0"/>
           </a:p>
@@ -10060,9 +9921,9 @@
                 <a:solidFill>
                   <a:srgbClr val="9A6A08"/>
                 </a:solidFill>
-                <a:latin typeface="Arial" pitchFamily="34" charset="0"/>
-                <a:ea typeface="Arial" pitchFamily="34" charset="-122"/>
-                <a:cs typeface="Arial" pitchFamily="34" charset="-120"/>
+                <a:latin typeface="Inter" pitchFamily="34" charset="0"/>
+                <a:ea typeface="Inter" pitchFamily="34" charset="-122"/>
+                <a:cs typeface="Inter" pitchFamily="34" charset="-120"/>
               </a:rPr>
               <a:t>GETTING STARTED</a:t>
             </a:r>
@@ -10074,9 +9935,7 @@
         <p:nvSpPr>
           <p:cNvPr id="3" name="Text 1"/>
           <p:cNvSpPr/>
-          <p:nvPr>
-            <p:ph type="title"/>
-          </p:nvPr>
+          <p:nvPr/>
         </p:nvSpPr>
         <p:spPr>
           <a:xfrm>
@@ -10102,13 +9961,13 @@
               <a:buNone/>
             </a:pPr>
             <a:r>
-              <a:rPr lang="en-US" sz="3600" b="1" i="0" dirty="0">
+              <a:rPr lang="en-US" sz="3600" b="1" dirty="0">
                 <a:solidFill>
                   <a:srgbClr val="16191E"/>
                 </a:solidFill>
-                <a:latin typeface="Arial" pitchFamily="34" charset="0"/>
-                <a:ea typeface="Arial" pitchFamily="34" charset="-122"/>
-                <a:cs typeface="Arial" pitchFamily="34" charset="-120"/>
+                <a:latin typeface="Inter" pitchFamily="34" charset="0"/>
+                <a:ea typeface="Inter" pitchFamily="34" charset="-122"/>
+                <a:cs typeface="Inter" pitchFamily="34" charset="-120"/>
               </a:rPr>
               <a:t>Start free, without an account</a:t>
             </a:r>
@@ -10177,9 +10036,9 @@
                 <a:solidFill>
                   <a:srgbClr val="9A6A08"/>
                 </a:solidFill>
-                <a:latin typeface="Arial" pitchFamily="34" charset="0"/>
-                <a:ea typeface="Arial" pitchFamily="34" charset="-122"/>
-                <a:cs typeface="Arial" pitchFamily="34" charset="-120"/>
+                <a:latin typeface="Inter" pitchFamily="34" charset="0"/>
+                <a:ea typeface="Inter" pitchFamily="34" charset="-122"/>
+                <a:cs typeface="Inter" pitchFamily="34" charset="-120"/>
               </a:rPr>
               <a:t>Find the bug</a:t>
             </a:r>
@@ -10221,9 +10080,9 @@
                 <a:solidFill>
                   <a:srgbClr val="16191E"/>
                 </a:solidFill>
-                <a:latin typeface="Arial" pitchFamily="34" charset="0"/>
-                <a:ea typeface="Arial" pitchFamily="34" charset="-122"/>
-                <a:cs typeface="Arial" pitchFamily="34" charset="-120"/>
+                <a:latin typeface="Inter" pitchFamily="34" charset="0"/>
+                <a:ea typeface="Inter" pitchFamily="34" charset="-122"/>
+                <a:cs typeface="Inter" pitchFamily="34" charset="-120"/>
               </a:rPr>
               <a:t>Chaos tester</a:t>
             </a:r>
@@ -10265,9 +10124,9 @@
                 <a:solidFill>
                   <a:srgbClr val="4A5058"/>
                 </a:solidFill>
-                <a:latin typeface="Arial" pitchFamily="34" charset="0"/>
-                <a:ea typeface="Arial" pitchFamily="34" charset="-122"/>
-                <a:cs typeface="Arial" pitchFamily="34" charset="-120"/>
+                <a:latin typeface="Inter" pitchFamily="34" charset="0"/>
+                <a:ea typeface="Inter" pitchFamily="34" charset="-122"/>
+                <a:cs typeface="Inter" pitchFamily="34" charset="-120"/>
               </a:rPr>
               <a:t>Shows the calls an agent would run twice, and agentraas scan checks an MCP server. Free, no signup, both run in CI.</a:t>
             </a:r>
@@ -10359,9 +10218,9 @@
                 <a:solidFill>
                   <a:srgbClr val="9A6A08"/>
                 </a:solidFill>
-                <a:latin typeface="Arial" pitchFamily="34" charset="0"/>
-                <a:ea typeface="Arial" pitchFamily="34" charset="-122"/>
-                <a:cs typeface="Arial" pitchFamily="34" charset="-120"/>
+                <a:latin typeface="Inter" pitchFamily="34" charset="0"/>
+                <a:ea typeface="Inter" pitchFamily="34" charset="-122"/>
+                <a:cs typeface="Inter" pitchFamily="34" charset="-120"/>
               </a:rPr>
               <a:t>Fix it in code</a:t>
             </a:r>
@@ -10403,9 +10262,9 @@
                 <a:solidFill>
                   <a:srgbClr val="16191E"/>
                 </a:solidFill>
-                <a:latin typeface="Arial" pitchFamily="34" charset="0"/>
-                <a:ea typeface="Arial" pitchFamily="34" charset="-122"/>
-                <a:cs typeface="Arial" pitchFamily="34" charset="-120"/>
+                <a:latin typeface="Inter" pitchFamily="34" charset="0"/>
+                <a:ea typeface="Inter" pitchFamily="34" charset="-122"/>
+                <a:cs typeface="Inter" pitchFamily="34" charset="-120"/>
               </a:rPr>
               <a:t>Library and MCP wrap</a:t>
             </a:r>
@@ -10447,9 +10306,9 @@
                 <a:solidFill>
                   <a:srgbClr val="4A5058"/>
                 </a:solidFill>
-                <a:latin typeface="Arial" pitchFamily="34" charset="0"/>
-                <a:ea typeface="Arial" pitchFamily="34" charset="-122"/>
-                <a:cs typeface="Arial" pitchFamily="34" charset="-120"/>
+                <a:latin typeface="Inter" pitchFamily="34" charset="0"/>
+                <a:ea typeface="Inter" pitchFamily="34" charset="-122"/>
+                <a:cs typeface="Inter" pitchFamily="34" charset="-120"/>
               </a:rPr>
               <a:t>An exactly-once decorator, and one command that protects any MCP server.</a:t>
             </a:r>
@@ -10488,12 +10347,12 @@
         </p:nvSpPr>
         <p:spPr>
           <a:xfrm>
-            <a:off x="8271966" y="2077541"/>
-            <a:ext cx="3107234" cy="1754981"/>
+            <a:off x="8271966" y="1967111"/>
+            <a:ext cx="3107234" cy="1975941"/>
           </a:xfrm>
           <a:prstGeom prst="roundRect">
             <a:avLst>
-              <a:gd name="adj" fmla="val 7237"/>
+              <a:gd name="adj" fmla="val 6427"/>
             </a:avLst>
           </a:prstGeom>
           <a:solidFill>
@@ -10510,7 +10369,7 @@
         </p:nvSpPr>
         <p:spPr>
           <a:xfrm>
-            <a:off x="8500566" y="2306141"/>
+            <a:off x="8500566" y="2195711"/>
             <a:ext cx="2729535" cy="238720"/>
           </a:xfrm>
           <a:prstGeom prst="rect">
@@ -10536,9 +10395,9 @@
                 <a:solidFill>
                   <a:srgbClr val="F2B544"/>
                 </a:solidFill>
-                <a:latin typeface="Arial" pitchFamily="34" charset="0"/>
-                <a:ea typeface="Arial" pitchFamily="34" charset="-122"/>
-                <a:cs typeface="Arial" pitchFamily="34" charset="-120"/>
+                <a:latin typeface="Inter" pitchFamily="34" charset="0"/>
+                <a:ea typeface="Inter" pitchFamily="34" charset="-122"/>
+                <a:cs typeface="Inter" pitchFamily="34" charset="-120"/>
               </a:rPr>
               <a:t>Run it as a platform</a:t>
             </a:r>
@@ -10554,7 +10413,7 @@
         </p:nvSpPr>
         <p:spPr>
           <a:xfrm>
-            <a:off x="8500566" y="2608362"/>
+            <a:off x="8500566" y="2497931"/>
             <a:ext cx="2729535" cy="269180"/>
           </a:xfrm>
           <a:prstGeom prst="rect">
@@ -10580,9 +10439,9 @@
                 <a:solidFill>
                   <a:srgbClr val="ECEFF3"/>
                 </a:solidFill>
-                <a:latin typeface="Arial" pitchFamily="34" charset="0"/>
-                <a:ea typeface="Arial" pitchFamily="34" charset="-122"/>
-                <a:cs typeface="Arial" pitchFamily="34" charset="-120"/>
+                <a:latin typeface="Inter" pitchFamily="34" charset="0"/>
+                <a:ea typeface="Inter" pitchFamily="34" charset="-122"/>
+                <a:cs typeface="Inter" pitchFamily="34" charset="-120"/>
               </a:rPr>
               <a:t>Self-host it, free</a:t>
             </a:r>
@@ -10598,8 +10457,8 @@
         </p:nvSpPr>
         <p:spPr>
           <a:xfrm>
-            <a:off x="8500566" y="2941042"/>
-            <a:ext cx="2729535" cy="688280"/>
+            <a:off x="8500566" y="2830612"/>
+            <a:ext cx="2729535" cy="909241"/>
           </a:xfrm>
           <a:prstGeom prst="rect">
             <a:avLst/>
@@ -10624,9 +10483,9 @@
                 <a:solidFill>
                   <a:srgbClr val="B8C0CB"/>
                 </a:solidFill>
-                <a:latin typeface="Arial" pitchFamily="34" charset="0"/>
-                <a:ea typeface="Arial" pitchFamily="34" charset="-122"/>
-                <a:cs typeface="Arial" pitchFamily="34" charset="-120"/>
+                <a:latin typeface="Inter" pitchFamily="34" charset="0"/>
+                <a:ea typeface="Inter" pitchFamily="34" charset="-122"/>
+                <a:cs typeface="Inter" pitchFamily="34" charset="-120"/>
               </a:rPr>
               <a:t>Exactly-once, policies, approvals, SSO, undo and the audit trail on Linux, macOS or Windows, no action limit.</a:t>
             </a:r>
@@ -10672,9 +10531,9 @@
                 <a:solidFill>
                   <a:srgbClr val="4A5058"/>
                 </a:solidFill>
-                <a:latin typeface="Arial" pitchFamily="34" charset="0"/>
-                <a:ea typeface="Arial" pitchFamily="34" charset="-122"/>
-                <a:cs typeface="Arial" pitchFamily="34" charset="-120"/>
+                <a:latin typeface="Inter" pitchFamily="34" charset="0"/>
+                <a:ea typeface="Inter" pitchFamily="34" charset="-122"/>
+                <a:cs typeface="Inter" pitchFamily="34" charset="-120"/>
               </a:rPr>
               <a:t>Connect by</a:t>
             </a:r>
@@ -10683,9 +10542,9 @@
                 <a:solidFill>
                   <a:srgbClr val="4A5058"/>
                 </a:solidFill>
-                <a:latin typeface="Arial" pitchFamily="34" charset="0"/>
-                <a:ea typeface="Arial" pitchFamily="34" charset="-122"/>
-                <a:cs typeface="Arial" pitchFamily="34" charset="-120"/>
+                <a:latin typeface="Inter" pitchFamily="34" charset="0"/>
+                <a:ea typeface="Inter" pitchFamily="34" charset="-122"/>
+                <a:cs typeface="Inter" pitchFamily="34" charset="-120"/>
               </a:rPr>
               <a:t> webhook, Python or TypeScript SDK, or MCP</a:t>
             </a:r>
@@ -10731,9 +10590,9 @@
                 <a:solidFill>
                   <a:srgbClr val="4A5058"/>
                 </a:solidFill>
-                <a:latin typeface="Arial" pitchFamily="34" charset="0"/>
-                <a:ea typeface="Arial" pitchFamily="34" charset="-122"/>
-                <a:cs typeface="Arial" pitchFamily="34" charset="-120"/>
+                <a:latin typeface="Inter" pitchFamily="34" charset="0"/>
+                <a:ea typeface="Inter" pitchFamily="34" charset="-122"/>
+                <a:cs typeface="Inter" pitchFamily="34" charset="-120"/>
               </a:rPr>
               <a:t>Works with</a:t>
             </a:r>
@@ -10742,9 +10601,9 @@
                 <a:solidFill>
                   <a:srgbClr val="4A5058"/>
                 </a:solidFill>
-                <a:latin typeface="Arial" pitchFamily="34" charset="0"/>
-                <a:ea typeface="Arial" pitchFamily="34" charset="-122"/>
-                <a:cs typeface="Arial" pitchFamily="34" charset="-120"/>
+                <a:latin typeface="Inter" pitchFamily="34" charset="0"/>
+                <a:ea typeface="Inter" pitchFamily="34" charset="-122"/>
+                <a:cs typeface="Inter" pitchFamily="34" charset="-120"/>
               </a:rPr>
               <a:t> n8n (community node), LangChain, CrewAI and any HTTP client</a:t>
             </a:r>
@@ -10790,9 +10649,9 @@
                 <a:solidFill>
                   <a:srgbClr val="4A5058"/>
                 </a:solidFill>
-                <a:latin typeface="Arial" pitchFamily="34" charset="0"/>
-                <a:ea typeface="Arial" pitchFamily="34" charset="-122"/>
-                <a:cs typeface="Arial" pitchFamily="34" charset="-120"/>
+                <a:latin typeface="Inter" pitchFamily="34" charset="0"/>
+                <a:ea typeface="Inter" pitchFamily="34" charset="-122"/>
+                <a:cs typeface="Inter" pitchFamily="34" charset="-120"/>
               </a:rPr>
               <a:t>Found through</a:t>
             </a:r>
@@ -10801,9 +10660,9 @@
                 <a:solidFill>
                   <a:srgbClr val="4A5058"/>
                 </a:solidFill>
-                <a:latin typeface="Arial" pitchFamily="34" charset="0"/>
-                <a:ea typeface="Arial" pitchFamily="34" charset="-122"/>
-                <a:cs typeface="Arial" pitchFamily="34" charset="-120"/>
+                <a:latin typeface="Inter" pitchFamily="34" charset="0"/>
+                <a:ea typeface="Inter" pitchFamily="34" charset="-122"/>
+                <a:cs typeface="Inter" pitchFamily="34" charset="-120"/>
               </a:rPr>
               <a:t> PyPI, npm, GitHub and the official MCP Registry</a:t>
             </a:r>
@@ -10877,9 +10736,9 @@
                 <a:solidFill>
                   <a:srgbClr val="9A6A08"/>
                 </a:solidFill>
-                <a:latin typeface="Arial" pitchFamily="34" charset="0"/>
-                <a:ea typeface="Arial" pitchFamily="34" charset="-122"/>
-                <a:cs typeface="Arial" pitchFamily="34" charset="-120"/>
+                <a:latin typeface="Inter" pitchFamily="34" charset="0"/>
+                <a:ea typeface="Inter" pitchFamily="34" charset="-122"/>
+                <a:cs typeface="Inter" pitchFamily="34" charset="-120"/>
               </a:rPr>
               <a:t>BUILT FOR THE CRITICAL PATH</a:t>
             </a:r>
@@ -10891,9 +10750,7 @@
         <p:nvSpPr>
           <p:cNvPr id="3" name="Text 1"/>
           <p:cNvSpPr/>
-          <p:nvPr>
-            <p:ph type="title"/>
-          </p:nvPr>
+          <p:nvPr/>
         </p:nvSpPr>
         <p:spPr>
           <a:xfrm>
@@ -10919,13 +10776,13 @@
               <a:buNone/>
             </a:pPr>
             <a:r>
-              <a:rPr lang="en-US" sz="3600" b="1" i="0" dirty="0">
+              <a:rPr lang="en-US" sz="3600" b="1" dirty="0">
                 <a:solidFill>
                   <a:srgbClr val="16191E"/>
                 </a:solidFill>
-                <a:latin typeface="Arial" pitchFamily="34" charset="0"/>
-                <a:ea typeface="Arial" pitchFamily="34" charset="-122"/>
-                <a:cs typeface="Arial" pitchFamily="34" charset="-120"/>
+                <a:latin typeface="Inter" pitchFamily="34" charset="0"/>
+                <a:ea typeface="Inter" pitchFamily="34" charset="-122"/>
+                <a:cs typeface="Inter" pitchFamily="34" charset="-120"/>
               </a:rPr>
               <a:t>Fast, open and self-hostable</a:t>
             </a:r>
@@ -10963,7 +10820,7 @@
         </p:nvSpPr>
         <p:spPr>
           <a:xfrm>
-            <a:off x="1168400" y="3153370"/>
+            <a:off x="1168400" y="3011091"/>
             <a:ext cx="762000" cy="63500"/>
           </a:xfrm>
           <a:prstGeom prst="roundRect">
@@ -10985,7 +10842,7 @@
         </p:nvSpPr>
         <p:spPr>
           <a:xfrm>
-            <a:off x="1168400" y="3369270"/>
+            <a:off x="1168400" y="3226991"/>
             <a:ext cx="4892294" cy="584200"/>
           </a:xfrm>
           <a:prstGeom prst="rect">
@@ -11011,9 +10868,9 @@
                 <a:solidFill>
                   <a:srgbClr val="ECEFF3"/>
                 </a:solidFill>
-                <a:latin typeface="Arial" pitchFamily="34" charset="0"/>
-                <a:ea typeface="Arial" pitchFamily="34" charset="-122"/>
-                <a:cs typeface="Arial" pitchFamily="34" charset="-120"/>
+                <a:latin typeface="Inter" pitchFamily="34" charset="0"/>
+                <a:ea typeface="Inter" pitchFamily="34" charset="-122"/>
+                <a:cs typeface="Inter" pitchFamily="34" charset="-120"/>
               </a:rPr>
               <a:t>2.1 to 2.4 ms</a:t>
             </a:r>
@@ -11029,8 +10886,8 @@
         </p:nvSpPr>
         <p:spPr>
           <a:xfrm>
-            <a:off x="1168400" y="4080470"/>
-            <a:ext cx="4892294" cy="594320"/>
+            <a:off x="1168400" y="3938191"/>
+            <a:ext cx="4892294" cy="878780"/>
           </a:xfrm>
           <a:prstGeom prst="rect">
             <a:avLst/>
@@ -11055,9 +10912,9 @@
                 <a:solidFill>
                   <a:srgbClr val="B8C0CB"/>
                 </a:solidFill>
-                <a:latin typeface="Arial" pitchFamily="34" charset="0"/>
-                <a:ea typeface="Arial" pitchFamily="34" charset="-122"/>
-                <a:cs typeface="Arial" pitchFamily="34" charset="-120"/>
+                <a:latin typeface="Inter" pitchFamily="34" charset="0"/>
+                <a:ea typeface="Inter" pitchFamily="34" charset="-122"/>
+                <a:cs typeface="Inter" pitchFamily="34" charset="-120"/>
               </a:rPr>
               <a:t>added per call at the median. A retried duplicate is answered from cache and never reaches the API.</a:t>
             </a:r>
@@ -11126,9 +10983,9 @@
                 <a:solidFill>
                   <a:srgbClr val="16191E"/>
                 </a:solidFill>
-                <a:latin typeface="Arial" pitchFamily="34" charset="0"/>
-                <a:ea typeface="Arial" pitchFamily="34" charset="-122"/>
-                <a:cs typeface="Arial" pitchFamily="34" charset="-120"/>
+                <a:latin typeface="Inter" pitchFamily="34" charset="0"/>
+                <a:ea typeface="Inter" pitchFamily="34" charset="-122"/>
+                <a:cs typeface="Inter" pitchFamily="34" charset="-120"/>
               </a:rPr>
               <a:t>Rust core</a:t>
             </a:r>
@@ -11170,9 +11027,9 @@
                 <a:solidFill>
                   <a:srgbClr val="4A5058"/>
                 </a:solidFill>
-                <a:latin typeface="Arial" pitchFamily="34" charset="0"/>
-                <a:ea typeface="Arial" pitchFamily="34" charset="-122"/>
-                <a:cs typeface="Arial" pitchFamily="34" charset="-120"/>
+                <a:latin typeface="Inter" pitchFamily="34" charset="0"/>
+                <a:ea typeface="Inter" pitchFamily="34" charset="-122"/>
+                <a:cs typeface="Inter" pitchFamily="34" charset="-120"/>
               </a:rPr>
               <a:t>An Axum and Tokio gateway on Postgres and Redis, serving production today.</a:t>
             </a:r>
@@ -11241,9 +11098,9 @@
                 <a:solidFill>
                   <a:srgbClr val="16191E"/>
                 </a:solidFill>
-                <a:latin typeface="Arial" pitchFamily="34" charset="0"/>
-                <a:ea typeface="Arial" pitchFamily="34" charset="-122"/>
-                <a:cs typeface="Arial" pitchFamily="34" charset="-120"/>
+                <a:latin typeface="Inter" pitchFamily="34" charset="0"/>
+                <a:ea typeface="Inter" pitchFamily="34" charset="-122"/>
+                <a:cs typeface="Inter" pitchFamily="34" charset="-120"/>
               </a:rPr>
               <a:t>Open source core</a:t>
             </a:r>
@@ -11285,9 +11142,9 @@
                 <a:solidFill>
                   <a:srgbClr val="4A5058"/>
                 </a:solidFill>
-                <a:latin typeface="Arial" pitchFamily="34" charset="0"/>
-                <a:ea typeface="Arial" pitchFamily="34" charset="-122"/>
-                <a:cs typeface="Arial" pitchFamily="34" charset="-120"/>
+                <a:latin typeface="Inter" pitchFamily="34" charset="0"/>
+                <a:ea typeface="Inter" pitchFamily="34" charset="-122"/>
+                <a:cs typeface="Inter" pitchFamily="34" charset="-120"/>
               </a:rPr>
               <a:t>MIT server core and every line of code public: you can read the code that guards your payments.</a:t>
             </a:r>
@@ -11356,9 +11213,9 @@
                 <a:solidFill>
                   <a:srgbClr val="16191E"/>
                 </a:solidFill>
-                <a:latin typeface="Arial" pitchFamily="34" charset="0"/>
-                <a:ea typeface="Arial" pitchFamily="34" charset="-122"/>
-                <a:cs typeface="Arial" pitchFamily="34" charset="-120"/>
+                <a:latin typeface="Inter" pitchFamily="34" charset="0"/>
+                <a:ea typeface="Inter" pitchFamily="34" charset="-122"/>
+                <a:cs typeface="Inter" pitchFamily="34" charset="-120"/>
               </a:rPr>
               <a:t>Runs where the data is</a:t>
             </a:r>
@@ -11400,11 +11257,11 @@
                 <a:solidFill>
                   <a:srgbClr val="4A5058"/>
                 </a:solidFill>
-                <a:latin typeface="Arial" pitchFamily="34" charset="0"/>
-                <a:ea typeface="Arial" pitchFamily="34" charset="-122"/>
-                <a:cs typeface="Arial" pitchFamily="34" charset="-120"/>
-              </a:rPr>
-              <a:t>One command installs it on the customer's own servers: Linux, macOS or Windows.</a:t>
+                <a:latin typeface="Inter" pitchFamily="34" charset="0"/>
+                <a:ea typeface="Inter" pitchFamily="34" charset="-122"/>
+                <a:cs typeface="Inter" pitchFamily="34" charset="-120"/>
+              </a:rPr>
+              <a:t>One command on Linux, macOS or Windows, Helm, or Terraform for AWS, Azure and Google Cloud.</a:t>
             </a:r>
             <a:endParaRPr lang="en-US" sz="1200" dirty="0"/>
           </a:p>
@@ -11444,9 +11301,9 @@
                 <a:solidFill>
                   <a:srgbClr val="6A7079"/>
                 </a:solidFill>
-                <a:latin typeface="Arial" pitchFamily="34" charset="0"/>
-                <a:ea typeface="Arial" pitchFamily="34" charset="-122"/>
-                <a:cs typeface="Arial" pitchFamily="34" charset="-120"/>
+                <a:latin typeface="Inter" pitchFamily="34" charset="0"/>
+                <a:ea typeface="Inter" pitchFamily="34" charset="-122"/>
+                <a:cs typeface="Inter" pitchFamily="34" charset="-120"/>
               </a:rPr>
               <a:t>Latency: one machine (Intel Core i3-12100), local stack, 500 sequential calls, three runs; script in the repo.</a:t>
             </a:r>
@@ -11463,38 +11320,38 @@
 </file>
 
 <file path=ppt/theme/theme1.xml><?xml version="1.0" encoding="utf-8"?>
-<a:theme xmlns:a="http://schemas.openxmlformats.org/drawingml/2006/main" name="AgentRaaS">
+<a:theme xmlns:a="http://schemas.openxmlformats.org/drawingml/2006/main" name="Office Theme">
   <a:themeElements>
-    <a:clrScheme name="AgentRaaS">
+    <a:clrScheme name="Office">
       <a:dk1>
-        <a:srgbClr val="16191E"/>
+        <a:sysClr val="windowText" lastClr="000000"/>
       </a:dk1>
       <a:lt1>
-        <a:srgbClr val="FFFFFF"/>
+        <a:sysClr val="window" lastClr="FFFFFF"/>
       </a:lt1>
       <a:dk2>
-        <a:srgbClr val="505356"/>
+        <a:srgbClr val="44546A"/>
       </a:dk2>
       <a:lt2>
-        <a:srgbClr val="E8E8E9"/>
+        <a:srgbClr val="E7E6E6"/>
       </a:lt2>
       <a:accent1>
-        <a:srgbClr val="9A6A08"/>
+        <a:srgbClr val="4472C4"/>
       </a:accent1>
       <a:accent2>
-        <a:srgbClr val="F2B544"/>
+        <a:srgbClr val="ED7D31"/>
       </a:accent2>
       <a:accent3>
-        <a:srgbClr val="4A5058"/>
+        <a:srgbClr val="A5A5A5"/>
       </a:accent3>
       <a:accent4>
-        <a:srgbClr val="B8C0CB"/>
+        <a:srgbClr val="FFC000"/>
       </a:accent4>
       <a:accent5>
-        <a:srgbClr val="6A7079"/>
+        <a:srgbClr val="5B9BD5"/>
       </a:accent5>
       <a:accent6>
-        <a:srgbClr val="9AA0A6"/>
+        <a:srgbClr val="70AD47"/>
       </a:accent6>
       <a:hlink>
         <a:srgbClr val="0563C1"/>
@@ -11503,9 +11360,9 @@
         <a:srgbClr val="954F72"/>
       </a:folHlink>
     </a:clrScheme>
-    <a:fontScheme name="AgentRaaS">
+    <a:fontScheme name="Office">
       <a:majorFont>
-        <a:latin typeface="Arial"/>
+        <a:latin typeface="Calibri Light" panose="020F0302020204030204"/>
         <a:ea typeface=""/>
         <a:cs typeface=""/>
         <a:font script="Jpan" typeface="游ゴシック Light"/>
@@ -11557,7 +11414,7 @@
         <a:font script="Tfng" typeface="Ebrima"/>
       </a:majorFont>
       <a:minorFont>
-        <a:latin typeface="Arial"/>
+        <a:latin typeface="Calibri" panose="020F0502020204030204"/>
         <a:ea typeface=""/>
         <a:cs typeface=""/>
         <a:font script="Jpan" typeface="游ゴシック"/>
@@ -11749,5 +11606,10 @@
   </a:themeElements>
   <a:objectDefaults/>
   <a:extraClrSchemeLst/>
+  <a:extLst>
+    <a:ext uri="{05A4C25C-085E-4340-85A3-A5531E510DB2}">
+      <thm15:themeFamily xmlns:thm15="http://schemas.microsoft.com/office/thememl/2012/main" name="Office Theme" id="{62F939B6-93AF-4DB8-9C6B-D6C7DFDC589F}" vid="{4A3C46E8-61CC-4603-A589-7422A47A8E4A}"/>
+    </a:ext>
+  </a:extLst>
 </a:theme>
 </file>
</xml_diff>